<commit_message>
fix(mobile-im): fix real transaction area parsing and thesis slide takeaway aggregation
</commit_message>
<xml_diff>
--- a/docs/test/stress/e2e-outputs/visual-qa/case01_seocho_medical/case01_seocho_medical_basic.pptx
+++ b/docs/test/stress/e2e-outputs/visual-qa/case01_seocho_medical/case01_seocho_medical_basic.pptx
@@ -14,10 +14,9 @@
     <p:sldId id="262" r:id="rId8"/>
     <p:sldId id="263" r:id="rId9"/>
     <p:sldId id="264" r:id="rId10"/>
-    <p:sldId id="265" r:id="rId11"/>
   </p:sldIdLst>
   <p:notesMasterIdLst>
-    <p:notesMasterId r:id="rId12"/>
+    <p:notesMasterId r:id="rId11"/>
   </p:notesMasterIdLst>
   <p:sldSz cx="12192000" cy="6858000"/>
   <p:notesSz cx="6858000" cy="12192000"/>
@@ -535,94 +534,6 @@
             <a:fld id="{F7021451-1387-4CA6-816F-3879F97B5CBC}" type="slidenum">
               <a:rPr lang="en-US"/>
               <a:t>1</a:t>
-            </a:fld>
-            <a:endParaRPr lang="en-US"/>
-          </a:p>
-        </p:txBody>
-      </p:sp>
-    </p:spTree>
-    <p:extLst>
-      <p:ext uri="{BB962C8B-B14F-4D97-AF65-F5344CB8AC3E}">
-        <p14:creationId xmlns:p14="http://schemas.microsoft.com/office/powerpoint/2010/main" val="1024086991"/>
-      </p:ext>
-    </p:extLst>
-  </p:cSld>
-  <p:clrMapOvr>
-    <a:masterClrMapping/>
-  </p:clrMapOvr>
-</p:notes>
-</file>
-
-<file path=ppt/notesSlides/notesSlide10.xml><?xml version="1.0" encoding="utf-8"?>
-<p:notes xmlns:a="http://schemas.openxmlformats.org/drawingml/2006/main" xmlns:r="http://schemas.openxmlformats.org/officeDocument/2006/relationships" xmlns:p="http://schemas.openxmlformats.org/presentationml/2006/main">
-  <p:cSld>
-    <p:spTree>
-      <p:nvGrpSpPr>
-        <p:cNvPr id="1" name=""/>
-        <p:cNvGrpSpPr/>
-        <p:nvPr/>
-      </p:nvGrpSpPr>
-      <p:grpSpPr>
-        <a:xfrm>
-          <a:off x="0" y="0"/>
-          <a:ext cx="0" cy="0"/>
-          <a:chOff x="0" y="0"/>
-          <a:chExt cx="0" cy="0"/>
-        </a:xfrm>
-      </p:grpSpPr>
-      <p:sp>
-        <p:nvSpPr>
-          <p:cNvPr id="2" name="Slide Image Placeholder 1"/>
-          <p:cNvSpPr>
-            <a:spLocks noGrp="1" noRot="1" noChangeAspect="1"/>
-          </p:cNvSpPr>
-          <p:nvPr>
-            <p:ph type="sldImg"/>
-          </p:nvPr>
-        </p:nvSpPr>
-        <p:spPr/>
-      </p:sp>
-      <p:sp>
-        <p:nvSpPr>
-          <p:cNvPr id="3" name="Notes Placeholder 2"/>
-          <p:cNvSpPr>
-            <a:spLocks noGrp="1"/>
-          </p:cNvSpPr>
-          <p:nvPr>
-            <p:ph type="body" idx="1"/>
-          </p:nvPr>
-        </p:nvSpPr>
-        <p:spPr/>
-        <p:txBody>
-          <a:bodyPr/>
-          <a:lstStyle/>
-          <a:p>
-            <a:r>
-              <a:rPr lang="en-US" dirty="0"/>
-              <a:t/>
-            </a:r>
-            <a:endParaRPr lang="en-US" dirty="0"/>
-          </a:p>
-        </p:txBody>
-      </p:sp>
-      <p:sp>
-        <p:nvSpPr>
-          <p:cNvPr id="4" name="Slide Number Placeholder 3"/>
-          <p:cNvSpPr>
-            <a:spLocks noGrp="1"/>
-          </p:cNvSpPr>
-          <p:nvPr>
-            <p:ph type="sldNum" sz="quarter" idx="10"/>
-          </p:nvPr>
-        </p:nvSpPr>
-        <p:spPr/>
-        <p:txBody>
-          <a:bodyPr/>
-          <a:lstStyle/>
-          <a:p>
-            <a:fld id="{F7021451-1387-4CA6-816F-3879F97B5CBC}" type="slidenum">
-              <a:rPr lang="en-US"/>
-              <a:t>10</a:t>
             </a:fld>
             <a:endParaRPr lang="en-US"/>
           </a:p>
@@ -1715,7 +1626,7 @@
             <a:avLst/>
           </a:prstGeom>
           <a:solidFill>
-            <a:srgbClr val="C8FF00"/>
+            <a:srgbClr val="6B8E00"/>
           </a:solidFill>
           <a:ln/>
         </p:spPr>
@@ -1783,7 +1694,7 @@
             <a:r>
               <a:rPr lang="en-US" sz="1500" b="1" dirty="0">
                 <a:solidFill>
-                  <a:srgbClr val="C8FF00"/>
+                  <a:srgbClr val="6B8E00"/>
                 </a:solidFill>
                 <a:latin typeface="Arial" pitchFamily="34" charset="0"/>
                 <a:ea typeface="Arial" pitchFamily="34" charset="-122"/>
@@ -1861,7 +1772,7 @@
             <a:r>
               <a:rPr lang="en-US" sz="1000" b="1" spc="250" kern="0" dirty="0">
                 <a:solidFill>
-                  <a:srgbClr val="C8FF00"/>
+                  <a:srgbClr val="6B8E00"/>
                 </a:solidFill>
                 <a:latin typeface="Arial" pitchFamily="34" charset="0"/>
                 <a:ea typeface="Arial" pitchFamily="34" charset="-122"/>
@@ -2090,11 +2001,11 @@
             </a:avLst>
           </a:prstGeom>
           <a:solidFill>
-            <a:srgbClr val="A3D900"/>
+            <a:srgbClr val="4F6A00"/>
           </a:solidFill>
           <a:ln w="12700">
             <a:solidFill>
-              <a:srgbClr val="C8FF00"/>
+              <a:srgbClr val="6B8E00"/>
             </a:solidFill>
             <a:prstDash val="solid"/>
           </a:ln>
@@ -2127,7 +2038,7 @@
             <a:r>
               <a:rPr lang="en-US" sz="2200" b="1" dirty="0">
                 <a:solidFill>
-                  <a:srgbClr val="F5FFCC"/>
+                  <a:srgbClr val="E8F5CC"/>
                 </a:solidFill>
                 <a:latin typeface="Pretendard" pitchFamily="34" charset="0"/>
                 <a:ea typeface="Pretendard" pitchFamily="34" charset="-122"/>
@@ -2273,1095 +2184,7 @@
           <a:noFill/>
           <a:ln w="6350">
             <a:solidFill>
-              <a:srgbClr val="C8FF00"/>
-            </a:solidFill>
-            <a:prstDash val="solid"/>
-          </a:ln>
-        </p:spPr>
-      </p:sp>
-    </p:spTree>
-  </p:cSld>
-  <p:clrMapOvr>
-    <a:masterClrMapping/>
-  </p:clrMapOvr>
-</p:sld>
-</file>
-
-<file path=ppt/slides/slide10.xml><?xml version="1.0" encoding="utf-8"?>
-<p:sld xmlns:a="http://schemas.openxmlformats.org/drawingml/2006/main" xmlns:r="http://schemas.openxmlformats.org/officeDocument/2006/relationships" xmlns:p="http://schemas.openxmlformats.org/presentationml/2006/main">
-  <p:cSld name="Slide 10">
-    <p:bg>
-      <p:bgPr>
-        <a:solidFill>
-          <a:srgbClr val="0F172A"/>
-        </a:solidFill>
-      </p:bgPr>
-    </p:bg>
-    <p:spTree>
-      <p:nvGrpSpPr>
-        <p:cNvPr id="1" name=""/>
-        <p:cNvGrpSpPr/>
-        <p:nvPr/>
-      </p:nvGrpSpPr>
-      <p:grpSpPr>
-        <a:xfrm>
-          <a:off x="0" y="0"/>
-          <a:ext cx="0" cy="0"/>
-          <a:chOff x="0" y="0"/>
-          <a:chExt cx="0" cy="0"/>
-        </a:xfrm>
-      </p:grpSpPr>
-      <p:sp>
-        <p:nvSpPr>
-          <p:cNvPr id="2" name="Shape 0"/>
-          <p:cNvSpPr/>
-          <p:nvPr/>
-        </p:nvSpPr>
-        <p:spPr>
-          <a:xfrm>
-            <a:off x="566928" y="384048"/>
-            <a:ext cx="45720" cy="566928"/>
-          </a:xfrm>
-          <a:prstGeom prst="rect">
-            <a:avLst/>
-          </a:prstGeom>
-          <a:solidFill>
-            <a:srgbClr val="C8FF00"/>
-          </a:solidFill>
-          <a:ln/>
-        </p:spPr>
-      </p:sp>
-      <p:sp>
-        <p:nvSpPr>
-          <p:cNvPr id="3" name="Text 1"/>
-          <p:cNvSpPr/>
-          <p:nvPr/>
-        </p:nvSpPr>
-        <p:spPr>
-          <a:xfrm>
-            <a:off x="749808" y="384048"/>
-            <a:ext cx="10874959" cy="182880"/>
-          </a:xfrm>
-          <a:prstGeom prst="rect">
-            <a:avLst/>
-          </a:prstGeom>
-          <a:noFill/>
-          <a:ln/>
-        </p:spPr>
-        <p:txBody>
-          <a:bodyPr wrap="square" lIns="0" tIns="0" rIns="0" bIns="0" rtlCol="0" anchor="ctr"/>
-          <a:lstStyle/>
-          <a:p>
-            <a:pPr indent="0" marL="0">
-              <a:buNone/>
-            </a:pPr>
-            <a:r>
-              <a:rPr lang="en-US" sz="950" b="1" spc="200" kern="0" dirty="0">
-                <a:solidFill>
-                  <a:srgbClr val="C8FF00"/>
-                </a:solidFill>
-                <a:latin typeface="Arial" pitchFamily="34" charset="0"/>
-                <a:ea typeface="Arial" pitchFamily="34" charset="-122"/>
-                <a:cs typeface="Arial" pitchFamily="34" charset="-120"/>
-              </a:rPr>
-              <a:t>10  Disclaimer</a:t>
-            </a:r>
-            <a:endParaRPr lang="en-US" sz="950" dirty="0"/>
-          </a:p>
-        </p:txBody>
-      </p:sp>
-      <p:sp>
-        <p:nvSpPr>
-          <p:cNvPr id="4" name="Text 2"/>
-          <p:cNvSpPr/>
-          <p:nvPr/>
-        </p:nvSpPr>
-        <p:spPr>
-          <a:xfrm>
-            <a:off x="749808" y="566928"/>
-            <a:ext cx="10874959" cy="384048"/>
-          </a:xfrm>
-          <a:prstGeom prst="rect">
-            <a:avLst/>
-          </a:prstGeom>
-          <a:noFill/>
-          <a:ln/>
-        </p:spPr>
-        <p:txBody>
-          <a:bodyPr wrap="square" lIns="0" tIns="0" rIns="0" bIns="0" rtlCol="0" anchor="ctr"/>
-          <a:lstStyle/>
-          <a:p>
-            <a:pPr indent="0" marL="0">
-              <a:buNone/>
-            </a:pPr>
-            <a:r>
-              <a:rPr lang="en-US" sz="2200" b="1" dirty="0">
-                <a:solidFill>
-                  <a:srgbClr val="FFFFFF"/>
-                </a:solidFill>
-                <a:latin typeface="Pretendard" pitchFamily="34" charset="0"/>
-                <a:ea typeface="Pretendard" pitchFamily="34" charset="-122"/>
-                <a:cs typeface="Pretendard" pitchFamily="34" charset="-120"/>
-              </a:rPr>
-              <a:t>표기 기준 및 면책</a:t>
-            </a:r>
-            <a:endParaRPr lang="en-US" sz="2200" dirty="0"/>
-          </a:p>
-        </p:txBody>
-      </p:sp>
-      <p:sp>
-        <p:nvSpPr>
-          <p:cNvPr id="5" name="Text 3"/>
-          <p:cNvSpPr/>
-          <p:nvPr/>
-        </p:nvSpPr>
-        <p:spPr>
-          <a:xfrm>
-            <a:off x="566928" y="1517904"/>
-            <a:ext cx="5486400" cy="237744"/>
-          </a:xfrm>
-          <a:prstGeom prst="rect">
-            <a:avLst/>
-          </a:prstGeom>
-          <a:noFill/>
-          <a:ln/>
-        </p:spPr>
-        <p:txBody>
-          <a:bodyPr wrap="square" lIns="0" tIns="0" rIns="0" bIns="0" rtlCol="0" anchor="ctr"/>
-          <a:lstStyle/>
-          <a:p>
-            <a:pPr indent="0" marL="0">
-              <a:buNone/>
-            </a:pPr>
-            <a:r>
-              <a:rPr lang="en-US" sz="1100" b="1" dirty="0">
-                <a:solidFill>
-                  <a:srgbClr val="FFFFFF"/>
-                </a:solidFill>
-                <a:latin typeface="Pretendard" pitchFamily="34" charset="0"/>
-                <a:ea typeface="Pretendard" pitchFamily="34" charset="-122"/>
-                <a:cs typeface="Pretendard" pitchFamily="34" charset="-120"/>
-              </a:rPr>
-              <a:t>데이터 출처 표기</a:t>
-            </a:r>
-            <a:endParaRPr lang="en-US" sz="1100" dirty="0"/>
-          </a:p>
-        </p:txBody>
-      </p:sp>
-      <p:sp>
-        <p:nvSpPr>
-          <p:cNvPr id="6" name="Shape 4"/>
-          <p:cNvSpPr/>
-          <p:nvPr/>
-        </p:nvSpPr>
-        <p:spPr>
-          <a:xfrm>
-            <a:off x="566928" y="1847088"/>
-            <a:ext cx="1417320" cy="347472"/>
-          </a:xfrm>
-          <a:prstGeom prst="roundRect">
-            <a:avLst>
-              <a:gd name="adj" fmla="val 10526"/>
-            </a:avLst>
-          </a:prstGeom>
-          <a:solidFill>
-            <a:srgbClr val="334155"/>
-          </a:solidFill>
-          <a:ln/>
-        </p:spPr>
-      </p:sp>
-      <p:sp>
-        <p:nvSpPr>
-          <p:cNvPr id="7" name="Text 5"/>
-          <p:cNvSpPr/>
-          <p:nvPr/>
-        </p:nvSpPr>
-        <p:spPr>
-          <a:xfrm>
-            <a:off x="566928" y="1847088"/>
-            <a:ext cx="1417320" cy="347472"/>
-          </a:xfrm>
-          <a:prstGeom prst="rect">
-            <a:avLst/>
-          </a:prstGeom>
-          <a:noFill/>
-          <a:ln/>
-        </p:spPr>
-        <p:txBody>
-          <a:bodyPr wrap="square" lIns="0" tIns="0" rIns="0" bIns="0" rtlCol="0" anchor="ctr"/>
-          <a:lstStyle/>
-          <a:p>
-            <a:pPr algn="ctr" indent="0" marL="0">
-              <a:buNone/>
-            </a:pPr>
-            <a:r>
-              <a:rPr lang="en-US" sz="950" b="1" dirty="0">
-                <a:solidFill>
-                  <a:srgbClr val="FFFFFF"/>
-                </a:solidFill>
-                <a:latin typeface="Pretendard" pitchFamily="34" charset="0"/>
-                <a:ea typeface="Pretendard" pitchFamily="34" charset="-122"/>
-                <a:cs typeface="Pretendard" pitchFamily="34" charset="-120"/>
-              </a:rPr>
-              <a:t>✓ 공부확인</a:t>
-            </a:r>
-            <a:endParaRPr lang="en-US" sz="950" dirty="0"/>
-          </a:p>
-        </p:txBody>
-      </p:sp>
-      <p:sp>
-        <p:nvSpPr>
-          <p:cNvPr id="8" name="Text 6"/>
-          <p:cNvSpPr/>
-          <p:nvPr/>
-        </p:nvSpPr>
-        <p:spPr>
-          <a:xfrm>
-            <a:off x="2139696" y="1828800"/>
-            <a:ext cx="3566160" cy="420624"/>
-          </a:xfrm>
-          <a:prstGeom prst="rect">
-            <a:avLst/>
-          </a:prstGeom>
-          <a:noFill/>
-          <a:ln/>
-        </p:spPr>
-        <p:txBody>
-          <a:bodyPr wrap="square" lIns="0" tIns="0" rIns="0" bIns="0" rtlCol="0" anchor="ctr"/>
-          <a:lstStyle/>
-          <a:p>
-            <a:pPr indent="0" marL="0">
-              <a:buNone/>
-            </a:pPr>
-            <a:r>
-              <a:rPr lang="en-US" sz="1000" dirty="0">
-                <a:solidFill>
-                  <a:srgbClr val="F1F5F9"/>
-                </a:solidFill>
-                <a:latin typeface="Pretendard" pitchFamily="34" charset="0"/>
-                <a:ea typeface="Pretendard" pitchFamily="34" charset="-122"/>
-                <a:cs typeface="Pretendard" pitchFamily="34" charset="-120"/>
-              </a:rPr>
-              <a:t>등기부·대장 등 공적 장부 직접 확인</a:t>
-            </a:r>
-            <a:endParaRPr lang="en-US" sz="1000" dirty="0"/>
-          </a:p>
-        </p:txBody>
-      </p:sp>
-      <p:sp>
-        <p:nvSpPr>
-          <p:cNvPr id="9" name="Text 7"/>
-          <p:cNvSpPr/>
-          <p:nvPr/>
-        </p:nvSpPr>
-        <p:spPr>
-          <a:xfrm>
-            <a:off x="5504688" y="1847088"/>
-            <a:ext cx="731520" cy="292608"/>
-          </a:xfrm>
-          <a:prstGeom prst="rect">
-            <a:avLst/>
-          </a:prstGeom>
-          <a:noFill/>
-          <a:ln/>
-        </p:spPr>
-        <p:txBody>
-          <a:bodyPr wrap="square" lIns="0" tIns="0" rIns="0" bIns="0" rtlCol="0" anchor="ctr"/>
-          <a:lstStyle/>
-          <a:p>
-            <a:pPr algn="r" indent="0" marL="0">
-              <a:buNone/>
-            </a:pPr>
-            <a:r>
-              <a:rPr lang="en-US" sz="1200" b="1" dirty="0">
-                <a:solidFill>
-                  <a:srgbClr val="FFFFFF"/>
-                </a:solidFill>
-                <a:latin typeface="Arial" pitchFamily="34" charset="0"/>
-                <a:ea typeface="Arial" pitchFamily="34" charset="-122"/>
-                <a:cs typeface="Arial" pitchFamily="34" charset="-120"/>
-              </a:rPr>
-              <a:t>1.00</a:t>
-            </a:r>
-            <a:endParaRPr lang="en-US" sz="1200" dirty="0"/>
-          </a:p>
-        </p:txBody>
-      </p:sp>
-      <p:sp>
-        <p:nvSpPr>
-          <p:cNvPr id="10" name="Shape 8"/>
-          <p:cNvSpPr/>
-          <p:nvPr/>
-        </p:nvSpPr>
-        <p:spPr>
-          <a:xfrm>
-            <a:off x="566928" y="2505456"/>
-            <a:ext cx="1417320" cy="347472"/>
-          </a:xfrm>
-          <a:prstGeom prst="roundRect">
-            <a:avLst>
-              <a:gd name="adj" fmla="val 10526"/>
-            </a:avLst>
-          </a:prstGeom>
-          <a:solidFill>
-            <a:srgbClr val="334155"/>
-          </a:solidFill>
-          <a:ln/>
-        </p:spPr>
-      </p:sp>
-      <p:sp>
-        <p:nvSpPr>
-          <p:cNvPr id="11" name="Text 9"/>
-          <p:cNvSpPr/>
-          <p:nvPr/>
-        </p:nvSpPr>
-        <p:spPr>
-          <a:xfrm>
-            <a:off x="566928" y="2505456"/>
-            <a:ext cx="1417320" cy="347472"/>
-          </a:xfrm>
-          <a:prstGeom prst="rect">
-            <a:avLst/>
-          </a:prstGeom>
-          <a:noFill/>
-          <a:ln/>
-        </p:spPr>
-        <p:txBody>
-          <a:bodyPr wrap="square" lIns="0" tIns="0" rIns="0" bIns="0" rtlCol="0" anchor="ctr"/>
-          <a:lstStyle/>
-          <a:p>
-            <a:pPr algn="ctr" indent="0" marL="0">
-              <a:buNone/>
-            </a:pPr>
-            <a:r>
-              <a:rPr lang="en-US" sz="950" b="1" dirty="0">
-                <a:solidFill>
-                  <a:srgbClr val="FFFFFF"/>
-                </a:solidFill>
-                <a:latin typeface="Pretendard" pitchFamily="34" charset="0"/>
-                <a:ea typeface="Pretendard" pitchFamily="34" charset="-122"/>
-                <a:cs typeface="Pretendard" pitchFamily="34" charset="-120"/>
-              </a:rPr>
-              <a:t>★ 전문가검증</a:t>
-            </a:r>
-            <a:endParaRPr lang="en-US" sz="950" dirty="0"/>
-          </a:p>
-        </p:txBody>
-      </p:sp>
-      <p:sp>
-        <p:nvSpPr>
-          <p:cNvPr id="12" name="Text 10"/>
-          <p:cNvSpPr/>
-          <p:nvPr/>
-        </p:nvSpPr>
-        <p:spPr>
-          <a:xfrm>
-            <a:off x="2139696" y="2487168"/>
-            <a:ext cx="3566160" cy="420624"/>
-          </a:xfrm>
-          <a:prstGeom prst="rect">
-            <a:avLst/>
-          </a:prstGeom>
-          <a:noFill/>
-          <a:ln/>
-        </p:spPr>
-        <p:txBody>
-          <a:bodyPr wrap="square" lIns="0" tIns="0" rIns="0" bIns="0" rtlCol="0" anchor="ctr"/>
-          <a:lstStyle/>
-          <a:p>
-            <a:pPr indent="0" marL="0">
-              <a:buNone/>
-            </a:pPr>
-            <a:r>
-              <a:rPr lang="en-US" sz="1000" dirty="0">
-                <a:solidFill>
-                  <a:srgbClr val="F1F5F9"/>
-                </a:solidFill>
-                <a:latin typeface="Pretendard" pitchFamily="34" charset="0"/>
-                <a:ea typeface="Pretendard" pitchFamily="34" charset="-122"/>
-                <a:cs typeface="Pretendard" pitchFamily="34" charset="-120"/>
-              </a:rPr>
-              <a:t>세무사·감정평가사 등 전문가 확인</a:t>
-            </a:r>
-            <a:endParaRPr lang="en-US" sz="1000" dirty="0"/>
-          </a:p>
-        </p:txBody>
-      </p:sp>
-      <p:sp>
-        <p:nvSpPr>
-          <p:cNvPr id="13" name="Text 11"/>
-          <p:cNvSpPr/>
-          <p:nvPr/>
-        </p:nvSpPr>
-        <p:spPr>
-          <a:xfrm>
-            <a:off x="5504688" y="2505456"/>
-            <a:ext cx="731520" cy="292608"/>
-          </a:xfrm>
-          <a:prstGeom prst="rect">
-            <a:avLst/>
-          </a:prstGeom>
-          <a:noFill/>
-          <a:ln/>
-        </p:spPr>
-        <p:txBody>
-          <a:bodyPr wrap="square" lIns="0" tIns="0" rIns="0" bIns="0" rtlCol="0" anchor="ctr"/>
-          <a:lstStyle/>
-          <a:p>
-            <a:pPr algn="r" indent="0" marL="0">
-              <a:buNone/>
-            </a:pPr>
-            <a:r>
-              <a:rPr lang="en-US" sz="1200" b="1" dirty="0">
-                <a:solidFill>
-                  <a:srgbClr val="FFFFFF"/>
-                </a:solidFill>
-                <a:latin typeface="Arial" pitchFamily="34" charset="0"/>
-                <a:ea typeface="Arial" pitchFamily="34" charset="-122"/>
-                <a:cs typeface="Arial" pitchFamily="34" charset="-120"/>
-              </a:rPr>
-              <a:t>0.95</a:t>
-            </a:r>
-            <a:endParaRPr lang="en-US" sz="1200" dirty="0"/>
-          </a:p>
-        </p:txBody>
-      </p:sp>
-      <p:sp>
-        <p:nvSpPr>
-          <p:cNvPr id="14" name="Shape 12"/>
-          <p:cNvSpPr/>
-          <p:nvPr/>
-        </p:nvSpPr>
-        <p:spPr>
-          <a:xfrm>
-            <a:off x="566928" y="3163824"/>
-            <a:ext cx="1417320" cy="347472"/>
-          </a:xfrm>
-          <a:prstGeom prst="roundRect">
-            <a:avLst>
-              <a:gd name="adj" fmla="val 10526"/>
-            </a:avLst>
-          </a:prstGeom>
-          <a:solidFill>
-            <a:srgbClr val="334155"/>
-          </a:solidFill>
-          <a:ln/>
-        </p:spPr>
-      </p:sp>
-      <p:sp>
-        <p:nvSpPr>
-          <p:cNvPr id="15" name="Text 13"/>
-          <p:cNvSpPr/>
-          <p:nvPr/>
-        </p:nvSpPr>
-        <p:spPr>
-          <a:xfrm>
-            <a:off x="566928" y="3163824"/>
-            <a:ext cx="1417320" cy="347472"/>
-          </a:xfrm>
-          <a:prstGeom prst="rect">
-            <a:avLst/>
-          </a:prstGeom>
-          <a:noFill/>
-          <a:ln/>
-        </p:spPr>
-        <p:txBody>
-          <a:bodyPr wrap="square" lIns="0" tIns="0" rIns="0" bIns="0" rtlCol="0" anchor="ctr"/>
-          <a:lstStyle/>
-          <a:p>
-            <a:pPr algn="ctr" indent="0" marL="0">
-              <a:buNone/>
-            </a:pPr>
-            <a:r>
-              <a:rPr lang="en-US" sz="950" b="1" dirty="0">
-                <a:solidFill>
-                  <a:srgbClr val="FFFFFF"/>
-                </a:solidFill>
-                <a:latin typeface="Pretendard" pitchFamily="34" charset="0"/>
-                <a:ea typeface="Pretendard" pitchFamily="34" charset="-122"/>
-                <a:cs typeface="Pretendard" pitchFamily="34" charset="-120"/>
-              </a:rPr>
-              <a:t>▲ 매도인고지</a:t>
-            </a:r>
-            <a:endParaRPr lang="en-US" sz="950" dirty="0"/>
-          </a:p>
-        </p:txBody>
-      </p:sp>
-      <p:sp>
-        <p:nvSpPr>
-          <p:cNvPr id="16" name="Text 14"/>
-          <p:cNvSpPr/>
-          <p:nvPr/>
-        </p:nvSpPr>
-        <p:spPr>
-          <a:xfrm>
-            <a:off x="2139696" y="3145536"/>
-            <a:ext cx="3566160" cy="420624"/>
-          </a:xfrm>
-          <a:prstGeom prst="rect">
-            <a:avLst/>
-          </a:prstGeom>
-          <a:noFill/>
-          <a:ln/>
-        </p:spPr>
-        <p:txBody>
-          <a:bodyPr wrap="square" lIns="0" tIns="0" rIns="0" bIns="0" rtlCol="0" anchor="ctr"/>
-          <a:lstStyle/>
-          <a:p>
-            <a:pPr indent="0" marL="0">
-              <a:buNone/>
-            </a:pPr>
-            <a:r>
-              <a:rPr lang="en-US" sz="1000" dirty="0">
-                <a:solidFill>
-                  <a:srgbClr val="F1F5F9"/>
-                </a:solidFill>
-                <a:latin typeface="Pretendard" pitchFamily="34" charset="0"/>
-                <a:ea typeface="Pretendard" pitchFamily="34" charset="-122"/>
-                <a:cs typeface="Pretendard" pitchFamily="34" charset="-120"/>
-              </a:rPr>
-              <a:t>매도인이 구두 또는 서면으로 고지</a:t>
-            </a:r>
-            <a:endParaRPr lang="en-US" sz="1000" dirty="0"/>
-          </a:p>
-        </p:txBody>
-      </p:sp>
-      <p:sp>
-        <p:nvSpPr>
-          <p:cNvPr id="17" name="Text 15"/>
-          <p:cNvSpPr/>
-          <p:nvPr/>
-        </p:nvSpPr>
-        <p:spPr>
-          <a:xfrm>
-            <a:off x="5504688" y="3163824"/>
-            <a:ext cx="731520" cy="292608"/>
-          </a:xfrm>
-          <a:prstGeom prst="rect">
-            <a:avLst/>
-          </a:prstGeom>
-          <a:noFill/>
-          <a:ln/>
-        </p:spPr>
-        <p:txBody>
-          <a:bodyPr wrap="square" lIns="0" tIns="0" rIns="0" bIns="0" rtlCol="0" anchor="ctr"/>
-          <a:lstStyle/>
-          <a:p>
-            <a:pPr algn="r" indent="0" marL="0">
-              <a:buNone/>
-            </a:pPr>
-            <a:r>
-              <a:rPr lang="en-US" sz="1200" b="1" dirty="0">
-                <a:solidFill>
-                  <a:srgbClr val="FFFFFF"/>
-                </a:solidFill>
-                <a:latin typeface="Arial" pitchFamily="34" charset="0"/>
-                <a:ea typeface="Arial" pitchFamily="34" charset="-122"/>
-                <a:cs typeface="Arial" pitchFamily="34" charset="-120"/>
-              </a:rPr>
-              <a:t>0.65</a:t>
-            </a:r>
-            <a:endParaRPr lang="en-US" sz="1200" dirty="0"/>
-          </a:p>
-        </p:txBody>
-      </p:sp>
-      <p:sp>
-        <p:nvSpPr>
-          <p:cNvPr id="18" name="Shape 16"/>
-          <p:cNvSpPr/>
-          <p:nvPr/>
-        </p:nvSpPr>
-        <p:spPr>
-          <a:xfrm>
-            <a:off x="566928" y="3822192"/>
-            <a:ext cx="1417320" cy="347472"/>
-          </a:xfrm>
-          <a:prstGeom prst="roundRect">
-            <a:avLst>
-              <a:gd name="adj" fmla="val 10526"/>
-            </a:avLst>
-          </a:prstGeom>
-          <a:solidFill>
-            <a:srgbClr val="334155"/>
-          </a:solidFill>
-          <a:ln/>
-        </p:spPr>
-      </p:sp>
-      <p:sp>
-        <p:nvSpPr>
-          <p:cNvPr id="19" name="Text 17"/>
-          <p:cNvSpPr/>
-          <p:nvPr/>
-        </p:nvSpPr>
-        <p:spPr>
-          <a:xfrm>
-            <a:off x="566928" y="3822192"/>
-            <a:ext cx="1417320" cy="347472"/>
-          </a:xfrm>
-          <a:prstGeom prst="rect">
-            <a:avLst/>
-          </a:prstGeom>
-          <a:noFill/>
-          <a:ln/>
-        </p:spPr>
-        <p:txBody>
-          <a:bodyPr wrap="square" lIns="0" tIns="0" rIns="0" bIns="0" rtlCol="0" anchor="ctr"/>
-          <a:lstStyle/>
-          <a:p>
-            <a:pPr algn="ctr" indent="0" marL="0">
-              <a:buNone/>
-            </a:pPr>
-            <a:r>
-              <a:rPr lang="en-US" sz="950" b="1" dirty="0">
-                <a:solidFill>
-                  <a:srgbClr val="FFFFFF"/>
-                </a:solidFill>
-                <a:latin typeface="Pretendard" pitchFamily="34" charset="0"/>
-                <a:ea typeface="Pretendard" pitchFamily="34" charset="-122"/>
-                <a:cs typeface="Pretendard" pitchFamily="34" charset="-120"/>
-              </a:rPr>
-              <a:t>● 중개인입력</a:t>
-            </a:r>
-            <a:endParaRPr lang="en-US" sz="950" dirty="0"/>
-          </a:p>
-        </p:txBody>
-      </p:sp>
-      <p:sp>
-        <p:nvSpPr>
-          <p:cNvPr id="20" name="Text 18"/>
-          <p:cNvSpPr/>
-          <p:nvPr/>
-        </p:nvSpPr>
-        <p:spPr>
-          <a:xfrm>
-            <a:off x="2139696" y="3803904"/>
-            <a:ext cx="3566160" cy="420624"/>
-          </a:xfrm>
-          <a:prstGeom prst="rect">
-            <a:avLst/>
-          </a:prstGeom>
-          <a:noFill/>
-          <a:ln/>
-        </p:spPr>
-        <p:txBody>
-          <a:bodyPr wrap="square" lIns="0" tIns="0" rIns="0" bIns="0" rtlCol="0" anchor="ctr"/>
-          <a:lstStyle/>
-          <a:p>
-            <a:pPr indent="0" marL="0">
-              <a:buNone/>
-            </a:pPr>
-            <a:r>
-              <a:rPr lang="en-US" sz="1000" dirty="0">
-                <a:solidFill>
-                  <a:srgbClr val="F1F5F9"/>
-                </a:solidFill>
-                <a:latin typeface="Pretendard" pitchFamily="34" charset="0"/>
-                <a:ea typeface="Pretendard" pitchFamily="34" charset="-122"/>
-                <a:cs typeface="Pretendard" pitchFamily="34" charset="-120"/>
-              </a:rPr>
-              <a:t>중개인 현장 조사 및 경험 기반 입력</a:t>
-            </a:r>
-            <a:endParaRPr lang="en-US" sz="1000" dirty="0"/>
-          </a:p>
-        </p:txBody>
-      </p:sp>
-      <p:sp>
-        <p:nvSpPr>
-          <p:cNvPr id="21" name="Text 19"/>
-          <p:cNvSpPr/>
-          <p:nvPr/>
-        </p:nvSpPr>
-        <p:spPr>
-          <a:xfrm>
-            <a:off x="5504688" y="3822192"/>
-            <a:ext cx="731520" cy="292608"/>
-          </a:xfrm>
-          <a:prstGeom prst="rect">
-            <a:avLst/>
-          </a:prstGeom>
-          <a:noFill/>
-          <a:ln/>
-        </p:spPr>
-        <p:txBody>
-          <a:bodyPr wrap="square" lIns="0" tIns="0" rIns="0" bIns="0" rtlCol="0" anchor="ctr"/>
-          <a:lstStyle/>
-          <a:p>
-            <a:pPr algn="r" indent="0" marL="0">
-              <a:buNone/>
-            </a:pPr>
-            <a:r>
-              <a:rPr lang="en-US" sz="1200" b="1" dirty="0">
-                <a:solidFill>
-                  <a:srgbClr val="FFFFFF"/>
-                </a:solidFill>
-                <a:latin typeface="Arial" pitchFamily="34" charset="0"/>
-                <a:ea typeface="Arial" pitchFamily="34" charset="-122"/>
-                <a:cs typeface="Arial" pitchFamily="34" charset="-120"/>
-              </a:rPr>
-              <a:t>0.60</a:t>
-            </a:r>
-            <a:endParaRPr lang="en-US" sz="1200" dirty="0"/>
-          </a:p>
-        </p:txBody>
-      </p:sp>
-      <p:sp>
-        <p:nvSpPr>
-          <p:cNvPr id="22" name="Shape 20"/>
-          <p:cNvSpPr/>
-          <p:nvPr/>
-        </p:nvSpPr>
-        <p:spPr>
-          <a:xfrm>
-            <a:off x="566928" y="4480560"/>
-            <a:ext cx="1417320" cy="347472"/>
-          </a:xfrm>
-          <a:prstGeom prst="roundRect">
-            <a:avLst>
-              <a:gd name="adj" fmla="val 10526"/>
-            </a:avLst>
-          </a:prstGeom>
-          <a:solidFill>
-            <a:srgbClr val="334155"/>
-          </a:solidFill>
-          <a:ln/>
-        </p:spPr>
-      </p:sp>
-      <p:sp>
-        <p:nvSpPr>
-          <p:cNvPr id="23" name="Text 21"/>
-          <p:cNvSpPr/>
-          <p:nvPr/>
-        </p:nvSpPr>
-        <p:spPr>
-          <a:xfrm>
-            <a:off x="566928" y="4480560"/>
-            <a:ext cx="1417320" cy="347472"/>
-          </a:xfrm>
-          <a:prstGeom prst="rect">
-            <a:avLst/>
-          </a:prstGeom>
-          <a:noFill/>
-          <a:ln/>
-        </p:spPr>
-        <p:txBody>
-          <a:bodyPr wrap="square" lIns="0" tIns="0" rIns="0" bIns="0" rtlCol="0" anchor="ctr"/>
-          <a:lstStyle/>
-          <a:p>
-            <a:pPr algn="ctr" indent="0" marL="0">
-              <a:buNone/>
-            </a:pPr>
-            <a:r>
-              <a:rPr lang="en-US" sz="950" b="1" dirty="0">
-                <a:solidFill>
-                  <a:srgbClr val="FFFFFF"/>
-                </a:solidFill>
-                <a:latin typeface="Pretendard" pitchFamily="34" charset="0"/>
-                <a:ea typeface="Pretendard" pitchFamily="34" charset="-122"/>
-                <a:cs typeface="Pretendard" pitchFamily="34" charset="-120"/>
-              </a:rPr>
-              <a:t>◇ AI추정·가정</a:t>
-            </a:r>
-            <a:endParaRPr lang="en-US" sz="950" dirty="0"/>
-          </a:p>
-        </p:txBody>
-      </p:sp>
-      <p:sp>
-        <p:nvSpPr>
-          <p:cNvPr id="24" name="Text 22"/>
-          <p:cNvSpPr/>
-          <p:nvPr/>
-        </p:nvSpPr>
-        <p:spPr>
-          <a:xfrm>
-            <a:off x="2139696" y="4462272"/>
-            <a:ext cx="3566160" cy="420624"/>
-          </a:xfrm>
-          <a:prstGeom prst="rect">
-            <a:avLst/>
-          </a:prstGeom>
-          <a:noFill/>
-          <a:ln/>
-        </p:spPr>
-        <p:txBody>
-          <a:bodyPr wrap="square" lIns="0" tIns="0" rIns="0" bIns="0" rtlCol="0" anchor="ctr"/>
-          <a:lstStyle/>
-          <a:p>
-            <a:pPr indent="0" marL="0">
-              <a:buNone/>
-            </a:pPr>
-            <a:r>
-              <a:rPr lang="en-US" sz="1000" dirty="0">
-                <a:solidFill>
-                  <a:srgbClr val="F1F5F9"/>
-                </a:solidFill>
-                <a:latin typeface="Pretendard" pitchFamily="34" charset="0"/>
-                <a:ea typeface="Pretendard" pitchFamily="34" charset="-122"/>
-                <a:cs typeface="Pretendard" pitchFamily="34" charset="-120"/>
-              </a:rPr>
-              <a:t>시나리오 분석 및 AI 모델 추정</a:t>
-            </a:r>
-            <a:endParaRPr lang="en-US" sz="1000" dirty="0"/>
-          </a:p>
-        </p:txBody>
-      </p:sp>
-      <p:sp>
-        <p:nvSpPr>
-          <p:cNvPr id="25" name="Text 23"/>
-          <p:cNvSpPr/>
-          <p:nvPr/>
-        </p:nvSpPr>
-        <p:spPr>
-          <a:xfrm>
-            <a:off x="5504688" y="4480560"/>
-            <a:ext cx="731520" cy="292608"/>
-          </a:xfrm>
-          <a:prstGeom prst="rect">
-            <a:avLst/>
-          </a:prstGeom>
-          <a:noFill/>
-          <a:ln/>
-        </p:spPr>
-        <p:txBody>
-          <a:bodyPr wrap="square" lIns="0" tIns="0" rIns="0" bIns="0" rtlCol="0" anchor="ctr"/>
-          <a:lstStyle/>
-          <a:p>
-            <a:pPr algn="r" indent="0" marL="0">
-              <a:buNone/>
-            </a:pPr>
-            <a:r>
-              <a:rPr lang="en-US" sz="1200" b="1" dirty="0">
-                <a:solidFill>
-                  <a:srgbClr val="FFFFFF"/>
-                </a:solidFill>
-                <a:latin typeface="Arial" pitchFamily="34" charset="0"/>
-                <a:ea typeface="Arial" pitchFamily="34" charset="-122"/>
-                <a:cs typeface="Arial" pitchFamily="34" charset="-120"/>
-              </a:rPr>
-              <a:t>0.30</a:t>
-            </a:r>
-            <a:endParaRPr lang="en-US" sz="1200" dirty="0"/>
-          </a:p>
-        </p:txBody>
-      </p:sp>
-      <p:sp>
-        <p:nvSpPr>
-          <p:cNvPr id="26" name="Text 24"/>
-          <p:cNvSpPr/>
-          <p:nvPr/>
-        </p:nvSpPr>
-        <p:spPr>
-          <a:xfrm>
-            <a:off x="6492240" y="1517904"/>
-            <a:ext cx="5129784" cy="237744"/>
-          </a:xfrm>
-          <a:prstGeom prst="rect">
-            <a:avLst/>
-          </a:prstGeom>
-          <a:noFill/>
-          <a:ln/>
-        </p:spPr>
-        <p:txBody>
-          <a:bodyPr wrap="square" lIns="0" tIns="0" rIns="0" bIns="0" rtlCol="0" anchor="ctr"/>
-          <a:lstStyle/>
-          <a:p>
-            <a:pPr indent="0" marL="0">
-              <a:buNone/>
-            </a:pPr>
-            <a:r>
-              <a:rPr lang="en-US" sz="1100" b="1" dirty="0">
-                <a:solidFill>
-                  <a:srgbClr val="FFFFFF"/>
-                </a:solidFill>
-                <a:latin typeface="Pretendard" pitchFamily="34" charset="0"/>
-                <a:ea typeface="Pretendard" pitchFamily="34" charset="-122"/>
-                <a:cs typeface="Pretendard" pitchFamily="34" charset="-120"/>
-              </a:rPr>
-              <a:t>면책 조항</a:t>
-            </a:r>
-            <a:endParaRPr lang="en-US" sz="1100" dirty="0"/>
-          </a:p>
-        </p:txBody>
-      </p:sp>
-      <p:sp>
-        <p:nvSpPr>
-          <p:cNvPr id="27" name="Shape 25"/>
-          <p:cNvSpPr/>
-          <p:nvPr/>
-        </p:nvSpPr>
-        <p:spPr>
-          <a:xfrm>
-            <a:off x="6492240" y="1847088"/>
-            <a:ext cx="5129784" cy="2615184"/>
-          </a:xfrm>
-          <a:prstGeom prst="roundRect">
-            <a:avLst>
-              <a:gd name="adj" fmla="val 1399"/>
-            </a:avLst>
-          </a:prstGeom>
-          <a:solidFill>
-            <a:srgbClr val="1E293B"/>
-          </a:solidFill>
-          <a:ln/>
-        </p:spPr>
-      </p:sp>
-      <p:sp>
-        <p:nvSpPr>
-          <p:cNvPr id="28" name="Text 26"/>
-          <p:cNvSpPr/>
-          <p:nvPr/>
-        </p:nvSpPr>
-        <p:spPr>
-          <a:xfrm>
-            <a:off x="6711696" y="2011680"/>
-            <a:ext cx="4690872" cy="2286000"/>
-          </a:xfrm>
-          <a:prstGeom prst="rect">
-            <a:avLst/>
-          </a:prstGeom>
-          <a:noFill/>
-          <a:ln/>
-        </p:spPr>
-        <p:txBody>
-          <a:bodyPr wrap="square" lIns="0" tIns="0" rIns="0" bIns="0" rtlCol="0" anchor="t"/>
-          <a:lstStyle/>
-          <a:p>
-            <a:pPr indent="0" marL="0">
-              <a:lnSpc>
-                <a:spcPct val="128000"/>
-              </a:lnSpc>
-              <a:buNone/>
-            </a:pPr>
-            <a:r>
-              <a:rPr lang="en-US" sz="930" dirty="0">
-                <a:solidFill>
-                  <a:srgbClr val="94A3B8"/>
-                </a:solidFill>
-                <a:latin typeface="Pretendard" pitchFamily="34" charset="0"/>
-                <a:ea typeface="Pretendard" pitchFamily="34" charset="-122"/>
-                <a:cs typeface="Pretendard" pitchFamily="34" charset="-120"/>
-              </a:rPr>
-              <a:t>본 자료는 투자 권유가 아니며, 기재된 정보의 정확성을 보증하지 않습니다.</a:t>
-            </a:r>
-            <a:endParaRPr lang="en-US" sz="930" dirty="0"/>
-          </a:p>
-        </p:txBody>
-      </p:sp>
-      <p:sp>
-        <p:nvSpPr>
-          <p:cNvPr id="29" name="Shape 27"/>
-          <p:cNvSpPr/>
-          <p:nvPr/>
-        </p:nvSpPr>
-        <p:spPr>
-          <a:xfrm>
-            <a:off x="566928" y="5230368"/>
-            <a:ext cx="11057839" cy="640080"/>
-          </a:xfrm>
-          <a:prstGeom prst="rect">
-            <a:avLst/>
-          </a:prstGeom>
-          <a:solidFill>
-            <a:srgbClr val="A3D900"/>
-          </a:solidFill>
-          <a:ln/>
-        </p:spPr>
-      </p:sp>
-      <p:sp>
-        <p:nvSpPr>
-          <p:cNvPr id="30" name="Text 28"/>
-          <p:cNvSpPr/>
-          <p:nvPr/>
-        </p:nvSpPr>
-        <p:spPr>
-          <a:xfrm>
-            <a:off x="786384" y="5321808"/>
-            <a:ext cx="10618927" cy="457200"/>
-          </a:xfrm>
-          <a:prstGeom prst="rect">
-            <a:avLst/>
-          </a:prstGeom>
-          <a:noFill/>
-          <a:ln/>
-        </p:spPr>
-        <p:txBody>
-          <a:bodyPr wrap="square" lIns="0" tIns="0" rIns="0" bIns="0" rtlCol="0" anchor="ctr"/>
-          <a:lstStyle/>
-          <a:p>
-            <a:pPr indent="0" marL="0">
-              <a:buNone/>
-            </a:pPr>
-            <a:r>
-              <a:rPr lang="en-US" sz="1000" dirty="0">
-                <a:solidFill>
-                  <a:srgbClr val="F5FFCC"/>
-                </a:solidFill>
-                <a:latin typeface="Pretendard" pitchFamily="34" charset="0"/>
-                <a:ea typeface="Pretendard" pitchFamily="34" charset="-122"/>
-                <a:cs typeface="Pretendard" pitchFamily="34" charset="-120"/>
-              </a:rPr>
-              <a:t>리얼티코리아 중개법인 · </a:t>
-            </a:r>
-            <a:endParaRPr lang="en-US" sz="1000" dirty="0"/>
-          </a:p>
-        </p:txBody>
-      </p:sp>
-      <p:sp>
-        <p:nvSpPr>
-          <p:cNvPr id="31" name="Text 29"/>
-          <p:cNvSpPr/>
-          <p:nvPr/>
-        </p:nvSpPr>
-        <p:spPr>
-          <a:xfrm>
-            <a:off x="566928" y="6419088"/>
-            <a:ext cx="11057839" cy="201168"/>
-          </a:xfrm>
-          <a:prstGeom prst="rect">
-            <a:avLst/>
-          </a:prstGeom>
-          <a:noFill/>
-          <a:ln/>
-        </p:spPr>
-        <p:txBody>
-          <a:bodyPr wrap="square" lIns="0" tIns="0" rIns="0" bIns="0" rtlCol="0" anchor="ctr"/>
-          <a:lstStyle/>
-          <a:p>
-            <a:pPr algn="ctr" indent="0" marL="0">
-              <a:buNone/>
-            </a:pPr>
-            <a:r>
-              <a:rPr lang="en-US" sz="750" dirty="0">
-                <a:solidFill>
-                  <a:srgbClr val="64748B"/>
-                </a:solidFill>
-                <a:latin typeface="Pretendard" pitchFamily="34" charset="0"/>
-                <a:ea typeface="Pretendard" pitchFamily="34" charset="-122"/>
-                <a:cs typeface="Pretendard" pitchFamily="34" charset="-120"/>
-              </a:rPr>
-              <a:t>크리딜  ·    ·  10</a:t>
-            </a:r>
-            <a:endParaRPr lang="en-US" sz="750" dirty="0"/>
-          </a:p>
-        </p:txBody>
-      </p:sp>
-      <p:sp>
-        <p:nvSpPr>
-          <p:cNvPr id="32" name="Shape 30"/>
-          <p:cNvSpPr/>
-          <p:nvPr/>
-        </p:nvSpPr>
-        <p:spPr>
-          <a:xfrm>
-            <a:off x="4437172" y="6382512"/>
-            <a:ext cx="3317352" cy="0"/>
-          </a:xfrm>
-          <a:prstGeom prst="line">
-            <a:avLst/>
-          </a:prstGeom>
-          <a:noFill/>
-          <a:ln w="6350">
-            <a:solidFill>
-              <a:srgbClr val="C8FF00"/>
+              <a:srgbClr val="6B8E00"/>
             </a:solidFill>
             <a:prstDash val="solid"/>
           </a:ln>
@@ -3414,7 +2237,7 @@
             <a:avLst/>
           </a:prstGeom>
           <a:solidFill>
-            <a:srgbClr val="C8FF00"/>
+            <a:srgbClr val="6B8E00"/>
           </a:solidFill>
           <a:ln/>
         </p:spPr>
@@ -3446,7 +2269,7 @@
             <a:r>
               <a:rPr lang="en-US" sz="950" b="1" spc="200" kern="0" dirty="0">
                 <a:solidFill>
-                  <a:srgbClr val="C8FF00"/>
+                  <a:srgbClr val="6B8E00"/>
                 </a:solidFill>
                 <a:latin typeface="Arial" pitchFamily="34" charset="0"/>
                 <a:ea typeface="Arial" pitchFamily="34" charset="-122"/>
@@ -3981,7 +2804,7 @@
           <a:noFill/>
           <a:ln w="6350">
             <a:solidFill>
-              <a:srgbClr val="C8FF00"/>
+              <a:srgbClr val="6B8E00"/>
             </a:solidFill>
             <a:prstDash val="solid"/>
           </a:ln>
@@ -4034,7 +2857,7 @@
             <a:avLst/>
           </a:prstGeom>
           <a:solidFill>
-            <a:srgbClr val="C8FF00"/>
+            <a:srgbClr val="6B8E00"/>
           </a:solidFill>
           <a:ln/>
         </p:spPr>
@@ -4066,7 +2889,7 @@
             <a:r>
               <a:rPr lang="en-US" sz="950" b="1" spc="200" kern="0" dirty="0">
                 <a:solidFill>
-                  <a:srgbClr val="C8FF00"/>
+                  <a:srgbClr val="6B8E00"/>
                 </a:solidFill>
                 <a:latin typeface="Arial" pitchFamily="34" charset="0"/>
                 <a:ea typeface="Arial" pitchFamily="34" charset="-122"/>
@@ -4534,7 +3357,7 @@
           <a:noFill/>
           <a:ln w="6350">
             <a:solidFill>
-              <a:srgbClr val="C8FF00"/>
+              <a:srgbClr val="6B8E00"/>
             </a:solidFill>
             <a:prstDash val="solid"/>
           </a:ln>
@@ -4587,7 +3410,7 @@
             <a:avLst/>
           </a:prstGeom>
           <a:solidFill>
-            <a:srgbClr val="C8FF00"/>
+            <a:srgbClr val="6B8E00"/>
           </a:solidFill>
           <a:ln/>
         </p:spPr>
@@ -4619,7 +3442,7 @@
             <a:r>
               <a:rPr lang="en-US" sz="950" b="1" spc="200" kern="0" dirty="0">
                 <a:solidFill>
-                  <a:srgbClr val="C8FF00"/>
+                  <a:srgbClr val="6B8E00"/>
                 </a:solidFill>
                 <a:latin typeface="Arial" pitchFamily="34" charset="0"/>
                 <a:ea typeface="Arial" pitchFamily="34" charset="-122"/>
@@ -5345,7 +4168,7 @@
           <a:noFill/>
           <a:ln w="8890">
             <a:solidFill>
-              <a:srgbClr val="C8FF00"/>
+              <a:srgbClr val="6B8E00"/>
             </a:solidFill>
             <a:prstDash val="solid"/>
           </a:ln>
@@ -5576,7 +4399,7 @@
           <a:noFill/>
           <a:ln w="6350">
             <a:solidFill>
-              <a:srgbClr val="C8FF00"/>
+              <a:srgbClr val="6B8E00"/>
             </a:solidFill>
             <a:prstDash val="solid"/>
           </a:ln>
@@ -5629,7 +4452,7 @@
             <a:avLst/>
           </a:prstGeom>
           <a:solidFill>
-            <a:srgbClr val="C8FF00"/>
+            <a:srgbClr val="6B8E00"/>
           </a:solidFill>
           <a:ln/>
         </p:spPr>
@@ -5661,7 +4484,7 @@
             <a:r>
               <a:rPr lang="en-US" sz="950" b="1" spc="200" kern="0" dirty="0">
                 <a:solidFill>
-                  <a:srgbClr val="C8FF00"/>
+                  <a:srgbClr val="6B8E00"/>
                 </a:solidFill>
                 <a:latin typeface="Arial" pitchFamily="34" charset="0"/>
                 <a:ea typeface="Arial" pitchFamily="34" charset="-122"/>
@@ -8551,7 +7374,7 @@
           <a:noFill/>
           <a:ln w="6350">
             <a:solidFill>
-              <a:srgbClr val="C8FF00"/>
+              <a:srgbClr val="6B8E00"/>
             </a:solidFill>
             <a:prstDash val="solid"/>
           </a:ln>
@@ -8604,7 +7427,7 @@
             <a:avLst/>
           </a:prstGeom>
           <a:solidFill>
-            <a:srgbClr val="C8FF00"/>
+            <a:srgbClr val="6B8E00"/>
           </a:solidFill>
           <a:ln/>
         </p:spPr>
@@ -8636,7 +7459,7 @@
             <a:r>
               <a:rPr lang="en-US" sz="950" b="1" spc="200" kern="0" dirty="0">
                 <a:solidFill>
-                  <a:srgbClr val="C8FF00"/>
+                  <a:srgbClr val="6B8E00"/>
                 </a:solidFill>
                 <a:latin typeface="Arial" pitchFamily="34" charset="0"/>
                 <a:ea typeface="Arial" pitchFamily="34" charset="-122"/>
@@ -8696,7 +7519,7 @@
         <p:spPr>
           <a:xfrm>
             <a:off x="566928" y="1325880"/>
-            <a:ext cx="6858000" cy="237744"/>
+            <a:ext cx="11057839" cy="237744"/>
           </a:xfrm>
           <a:prstGeom prst="rect">
             <a:avLst/>
@@ -8734,139 +7557,16 @@
         </p:nvSpPr>
         <p:spPr>
           <a:xfrm>
-            <a:off x="566928" y="1828800"/>
-            <a:ext cx="6858000" cy="2743200"/>
-          </a:xfrm>
-          <a:prstGeom prst="roundRect">
-            <a:avLst>
-              <a:gd name="adj" fmla="val 2000"/>
-            </a:avLst>
-          </a:prstGeom>
-          <a:solidFill>
-            <a:srgbClr val="DBEAFE"/>
-          </a:solidFill>
-          <a:ln/>
-        </p:spPr>
-      </p:sp>
-      <p:sp>
-        <p:nvSpPr>
-          <p:cNvPr id="7" name="Shape 5"/>
-          <p:cNvSpPr/>
-          <p:nvPr/>
-        </p:nvSpPr>
-        <p:spPr>
-          <a:xfrm>
-            <a:off x="566928" y="1883664"/>
-            <a:ext cx="36576" cy="2633472"/>
-          </a:xfrm>
-          <a:prstGeom prst="rect">
-            <a:avLst/>
-          </a:prstGeom>
-          <a:solidFill>
-            <a:srgbClr val="1D4ED8"/>
-          </a:solidFill>
-          <a:ln/>
-        </p:spPr>
-      </p:sp>
-      <p:sp>
-        <p:nvSpPr>
-          <p:cNvPr id="8" name="Text 6"/>
-          <p:cNvSpPr/>
-          <p:nvPr/>
-        </p:nvSpPr>
-        <p:spPr>
-          <a:xfrm>
-            <a:off x="749808" y="1938528"/>
-            <a:ext cx="6528816" cy="201168"/>
-          </a:xfrm>
-          <a:prstGeom prst="rect">
-            <a:avLst/>
-          </a:prstGeom>
-          <a:noFill/>
-          <a:ln/>
-        </p:spPr>
-        <p:txBody>
-          <a:bodyPr wrap="square" lIns="0" tIns="0" rIns="0" bIns="0" rtlCol="0" anchor="ctr"/>
-          <a:lstStyle/>
-          <a:p>
-            <a:pPr indent="0" marL="0">
-              <a:buNone/>
-            </a:pPr>
-            <a:r>
-              <a:rPr lang="en-US" sz="1050" b="1" dirty="0">
-                <a:solidFill>
-                  <a:srgbClr val="1D4ED8"/>
-                </a:solidFill>
-                <a:latin typeface="Pretendard" pitchFamily="34" charset="0"/>
-                <a:ea typeface="Pretendard" pitchFamily="34" charset="-122"/>
-                <a:cs typeface="Pretendard" pitchFamily="34" charset="-120"/>
-              </a:rPr>
-              <a:t>핵심 투자 가치 제안 (Value Proposition)</a:t>
-            </a:r>
-            <a:endParaRPr lang="en-US" sz="1050" dirty="0"/>
-          </a:p>
-        </p:txBody>
-      </p:sp>
-      <p:sp>
-        <p:nvSpPr>
-          <p:cNvPr id="9" name="Text 7"/>
-          <p:cNvSpPr/>
-          <p:nvPr/>
-        </p:nvSpPr>
-        <p:spPr>
-          <a:xfrm>
-            <a:off x="749808" y="2157984"/>
-            <a:ext cx="6528816" cy="2340864"/>
-          </a:xfrm>
-          <a:prstGeom prst="rect">
-            <a:avLst/>
-          </a:prstGeom>
-          <a:noFill/>
-          <a:ln/>
-        </p:spPr>
-        <p:txBody>
-          <a:bodyPr wrap="square" lIns="0" tIns="0" rIns="0" bIns="0" rtlCol="0" anchor="t"/>
-          <a:lstStyle/>
-          <a:p>
-            <a:pPr indent="0" marL="0">
-              <a:lnSpc>
-                <a:spcPct val="120000"/>
-              </a:lnSpc>
-              <a:buNone/>
-            </a:pPr>
-            <a:r>
-              <a:rPr lang="en-US" sz="930" dirty="0">
-                <a:solidFill>
-                  <a:srgbClr val="0F172A"/>
-                </a:solidFill>
-                <a:latin typeface="Pretendard" pitchFamily="34" charset="0"/>
-                <a:ea typeface="Pretendard" pitchFamily="34" charset="-122"/>
-                <a:cs typeface="Pretendard" pitchFamily="34" charset="-120"/>
-              </a:rPr>
-              <a:t>본 자산은 우수한 입지 경쟁력과 견고한 펀더멘털을 바탕으로 안정적인 현금흐름 창출과 중장기 자산 가치 상승(Capital Gain)을 동시에 실현할 수 있는 우량 투자 기회입니다.</a:t>
-            </a:r>
-            <a:endParaRPr lang="en-US" sz="930" dirty="0"/>
-          </a:p>
-        </p:txBody>
-      </p:sp>
-      <p:sp>
-        <p:nvSpPr>
-          <p:cNvPr id="10" name="Shape 8"/>
-          <p:cNvSpPr/>
-          <p:nvPr/>
-        </p:nvSpPr>
-        <p:spPr>
-          <a:xfrm>
-            <a:off x="7604608" y="1371600"/>
-            <a:ext cx="0" cy="4754880"/>
+            <a:off x="566928" y="1737360"/>
+            <a:ext cx="11057839" cy="0"/>
           </a:xfrm>
           <a:prstGeom prst="line">
             <a:avLst/>
           </a:prstGeom>
           <a:noFill/>
-          <a:ln w="8890">
+          <a:ln w="19050">
             <a:solidFill>
-              <a:srgbClr val="C8FF00"/>
+              <a:srgbClr val="6B8E00"/>
             </a:solidFill>
             <a:prstDash val="solid"/>
           </a:ln>
@@ -8874,18 +7574,18 @@
       </p:sp>
       <p:sp>
         <p:nvSpPr>
-          <p:cNvPr id="11" name="Shape 9"/>
-          <p:cNvSpPr/>
-          <p:nvPr/>
-        </p:nvSpPr>
-        <p:spPr>
-          <a:xfrm>
-            <a:off x="7784287" y="1536192"/>
-            <a:ext cx="3840480" cy="1005840"/>
+          <p:cNvPr id="7" name="Shape 5"/>
+          <p:cNvSpPr/>
+          <p:nvPr/>
+        </p:nvSpPr>
+        <p:spPr>
+          <a:xfrm>
+            <a:off x="566928" y="1965960"/>
+            <a:ext cx="3576218" cy="1188720"/>
           </a:xfrm>
           <a:prstGeom prst="roundRect">
             <a:avLst>
-              <a:gd name="adj" fmla="val 5455"/>
+              <a:gd name="adj" fmla="val 4615"/>
             </a:avLst>
           </a:prstGeom>
           <a:solidFill>
@@ -8901,14 +7601,14 @@
       </p:sp>
       <p:sp>
         <p:nvSpPr>
-          <p:cNvPr id="12" name="Text 10"/>
-          <p:cNvSpPr/>
-          <p:nvPr/>
-        </p:nvSpPr>
-        <p:spPr>
-          <a:xfrm>
-            <a:off x="7948879" y="1664208"/>
-            <a:ext cx="3511296" cy="201168"/>
+          <p:cNvPr id="8" name="Text 6"/>
+          <p:cNvSpPr/>
+          <p:nvPr/>
+        </p:nvSpPr>
+        <p:spPr>
+          <a:xfrm>
+            <a:off x="731520" y="2093976"/>
+            <a:ext cx="3247034" cy="201168"/>
           </a:xfrm>
           <a:prstGeom prst="rect">
             <a:avLst/>
@@ -8940,14 +7640,14 @@
       </p:sp>
       <p:sp>
         <p:nvSpPr>
-          <p:cNvPr id="13" name="Text 11"/>
-          <p:cNvSpPr/>
-          <p:nvPr/>
-        </p:nvSpPr>
-        <p:spPr>
-          <a:xfrm>
-            <a:off x="7948879" y="1847088"/>
-            <a:ext cx="3511296" cy="402336"/>
+          <p:cNvPr id="9" name="Text 7"/>
+          <p:cNvSpPr/>
+          <p:nvPr/>
+        </p:nvSpPr>
+        <p:spPr>
+          <a:xfrm>
+            <a:off x="731520" y="2276856"/>
+            <a:ext cx="3247034" cy="402336"/>
           </a:xfrm>
           <a:prstGeom prst="rect">
             <a:avLst/>
@@ -8965,7 +7665,7 @@
               <a:buNone/>
             </a:pPr>
             <a:r>
-              <a:rPr lang="en-US" sz="2500" b="1" dirty="0">
+              <a:rPr lang="en-US" sz="2200" b="1" dirty="0">
                 <a:solidFill>
                   <a:srgbClr val="0F172A"/>
                 </a:solidFill>
@@ -8975,24 +7675,24 @@
               </a:rPr>
               <a:t>165억 원</a:t>
             </a:r>
-            <a:endParaRPr lang="en-US" sz="2500" dirty="0"/>
-          </a:p>
-        </p:txBody>
-      </p:sp>
-      <p:sp>
-        <p:nvSpPr>
-          <p:cNvPr id="14" name="Shape 12"/>
-          <p:cNvSpPr/>
-          <p:nvPr/>
-        </p:nvSpPr>
-        <p:spPr>
-          <a:xfrm>
-            <a:off x="7784287" y="2670048"/>
-            <a:ext cx="3840480" cy="1005840"/>
+            <a:endParaRPr lang="en-US" sz="2200" dirty="0"/>
+          </a:p>
+        </p:txBody>
+      </p:sp>
+      <p:sp>
+        <p:nvSpPr>
+          <p:cNvPr id="10" name="Shape 8"/>
+          <p:cNvSpPr/>
+          <p:nvPr/>
+        </p:nvSpPr>
+        <p:spPr>
+          <a:xfrm>
+            <a:off x="4307738" y="1965960"/>
+            <a:ext cx="3576218" cy="1188720"/>
           </a:xfrm>
           <a:prstGeom prst="roundRect">
             <a:avLst>
-              <a:gd name="adj" fmla="val 5455"/>
+              <a:gd name="adj" fmla="val 4615"/>
             </a:avLst>
           </a:prstGeom>
           <a:solidFill>
@@ -9008,14 +7708,14 @@
       </p:sp>
       <p:sp>
         <p:nvSpPr>
-          <p:cNvPr id="15" name="Text 13"/>
-          <p:cNvSpPr/>
-          <p:nvPr/>
-        </p:nvSpPr>
-        <p:spPr>
-          <a:xfrm>
-            <a:off x="7948879" y="2798064"/>
-            <a:ext cx="3511296" cy="201168"/>
+          <p:cNvPr id="11" name="Text 9"/>
+          <p:cNvSpPr/>
+          <p:nvPr/>
+        </p:nvSpPr>
+        <p:spPr>
+          <a:xfrm>
+            <a:off x="4472330" y="2093976"/>
+            <a:ext cx="3247034" cy="201168"/>
           </a:xfrm>
           <a:prstGeom prst="rect">
             <a:avLst/>
@@ -9047,14 +7747,14 @@
       </p:sp>
       <p:sp>
         <p:nvSpPr>
-          <p:cNvPr id="16" name="Text 14"/>
-          <p:cNvSpPr/>
-          <p:nvPr/>
-        </p:nvSpPr>
-        <p:spPr>
-          <a:xfrm>
-            <a:off x="7948879" y="2980944"/>
-            <a:ext cx="3511296" cy="402336"/>
+          <p:cNvPr id="12" name="Text 10"/>
+          <p:cNvSpPr/>
+          <p:nvPr/>
+        </p:nvSpPr>
+        <p:spPr>
+          <a:xfrm>
+            <a:off x="4472330" y="2276856"/>
+            <a:ext cx="3247034" cy="402336"/>
           </a:xfrm>
           <a:prstGeom prst="rect">
             <a:avLst/>
@@ -9072,7 +7772,7 @@
               <a:buNone/>
             </a:pPr>
             <a:r>
-              <a:rPr lang="en-US" sz="1800" b="1" dirty="0">
+              <a:rPr lang="en-US" sz="2200" b="1" dirty="0">
                 <a:solidFill>
                   <a:srgbClr val="0F172A"/>
                 </a:solidFill>
@@ -9082,24 +7782,24 @@
               </a:rPr>
               <a:t>11억 5,000만 원</a:t>
             </a:r>
-            <a:endParaRPr lang="en-US" sz="1800" dirty="0"/>
-          </a:p>
-        </p:txBody>
-      </p:sp>
-      <p:sp>
-        <p:nvSpPr>
-          <p:cNvPr id="17" name="Shape 15"/>
-          <p:cNvSpPr/>
-          <p:nvPr/>
-        </p:nvSpPr>
-        <p:spPr>
-          <a:xfrm>
-            <a:off x="7784287" y="3803904"/>
-            <a:ext cx="3840480" cy="1005840"/>
+            <a:endParaRPr lang="en-US" sz="2200" dirty="0"/>
+          </a:p>
+        </p:txBody>
+      </p:sp>
+      <p:sp>
+        <p:nvSpPr>
+          <p:cNvPr id="13" name="Shape 11"/>
+          <p:cNvSpPr/>
+          <p:nvPr/>
+        </p:nvSpPr>
+        <p:spPr>
+          <a:xfrm>
+            <a:off x="8048549" y="1965960"/>
+            <a:ext cx="3576218" cy="1188720"/>
           </a:xfrm>
           <a:prstGeom prst="roundRect">
             <a:avLst>
-              <a:gd name="adj" fmla="val 5455"/>
+              <a:gd name="adj" fmla="val 4615"/>
             </a:avLst>
           </a:prstGeom>
           <a:solidFill>
@@ -9115,14 +7815,14 @@
       </p:sp>
       <p:sp>
         <p:nvSpPr>
-          <p:cNvPr id="18" name="Text 16"/>
-          <p:cNvSpPr/>
-          <p:nvPr/>
-        </p:nvSpPr>
-        <p:spPr>
-          <a:xfrm>
-            <a:off x="7948879" y="3931920"/>
-            <a:ext cx="3511296" cy="201168"/>
+          <p:cNvPr id="14" name="Text 12"/>
+          <p:cNvSpPr/>
+          <p:nvPr/>
+        </p:nvSpPr>
+        <p:spPr>
+          <a:xfrm>
+            <a:off x="8213141" y="2093976"/>
+            <a:ext cx="3247034" cy="201168"/>
           </a:xfrm>
           <a:prstGeom prst="rect">
             <a:avLst/>
@@ -9154,14 +7854,14 @@
       </p:sp>
       <p:sp>
         <p:nvSpPr>
-          <p:cNvPr id="19" name="Text 17"/>
-          <p:cNvSpPr/>
-          <p:nvPr/>
-        </p:nvSpPr>
-        <p:spPr>
-          <a:xfrm>
-            <a:off x="7948879" y="4114800"/>
-            <a:ext cx="3511296" cy="402336"/>
+          <p:cNvPr id="15" name="Text 13"/>
+          <p:cNvSpPr/>
+          <p:nvPr/>
+        </p:nvSpPr>
+        <p:spPr>
+          <a:xfrm>
+            <a:off x="8213141" y="2276856"/>
+            <a:ext cx="3247034" cy="402336"/>
           </a:xfrm>
           <a:prstGeom prst="rect">
             <a:avLst/>
@@ -9179,7 +7879,7 @@
               <a:buNone/>
             </a:pPr>
             <a:r>
-              <a:rPr lang="en-US" sz="1100" b="1" dirty="0">
+              <a:rPr lang="en-US" sz="2200" b="1" dirty="0">
                 <a:solidFill>
                   <a:srgbClr val="0F172A"/>
                 </a:solidFill>
@@ -9189,24 +7889,24 @@
               </a:rPr>
               <a:t>5,950만 원 (연 7억 1,400만 원)</a:t>
             </a:r>
-            <a:endParaRPr lang="en-US" sz="1100" dirty="0"/>
-          </a:p>
-        </p:txBody>
-      </p:sp>
-      <p:sp>
-        <p:nvSpPr>
-          <p:cNvPr id="20" name="Shape 18"/>
-          <p:cNvSpPr/>
-          <p:nvPr/>
-        </p:nvSpPr>
-        <p:spPr>
-          <a:xfrm>
-            <a:off x="7784287" y="4937760"/>
-            <a:ext cx="3840480" cy="1005840"/>
+            <a:endParaRPr lang="en-US" sz="2200" dirty="0"/>
+          </a:p>
+        </p:txBody>
+      </p:sp>
+      <p:sp>
+        <p:nvSpPr>
+          <p:cNvPr id="16" name="Shape 14"/>
+          <p:cNvSpPr/>
+          <p:nvPr/>
+        </p:nvSpPr>
+        <p:spPr>
+          <a:xfrm>
+            <a:off x="566928" y="3319272"/>
+            <a:ext cx="3576218" cy="1051560"/>
           </a:xfrm>
           <a:prstGeom prst="roundRect">
             <a:avLst>
-              <a:gd name="adj" fmla="val 5455"/>
+              <a:gd name="adj" fmla="val 5217"/>
             </a:avLst>
           </a:prstGeom>
           <a:solidFill>
@@ -9222,14 +7922,14 @@
       </p:sp>
       <p:sp>
         <p:nvSpPr>
-          <p:cNvPr id="21" name="Text 19"/>
-          <p:cNvSpPr/>
-          <p:nvPr/>
-        </p:nvSpPr>
-        <p:spPr>
-          <a:xfrm>
-            <a:off x="7948879" y="5065776"/>
-            <a:ext cx="3511296" cy="201168"/>
+          <p:cNvPr id="17" name="Text 15"/>
+          <p:cNvSpPr/>
+          <p:nvPr/>
+        </p:nvSpPr>
+        <p:spPr>
+          <a:xfrm>
+            <a:off x="731520" y="3447288"/>
+            <a:ext cx="3247034" cy="201168"/>
           </a:xfrm>
           <a:prstGeom prst="rect">
             <a:avLst/>
@@ -9261,14 +7961,14 @@
       </p:sp>
       <p:sp>
         <p:nvSpPr>
-          <p:cNvPr id="22" name="Text 20"/>
-          <p:cNvSpPr/>
-          <p:nvPr/>
-        </p:nvSpPr>
-        <p:spPr>
-          <a:xfrm>
-            <a:off x="7948879" y="5248656"/>
-            <a:ext cx="3511296" cy="402336"/>
+          <p:cNvPr id="18" name="Text 16"/>
+          <p:cNvSpPr/>
+          <p:nvPr/>
+        </p:nvSpPr>
+        <p:spPr>
+          <a:xfrm>
+            <a:off x="731520" y="3630168"/>
+            <a:ext cx="3247034" cy="402336"/>
           </a:xfrm>
           <a:prstGeom prst="rect">
             <a:avLst/>
@@ -9286,7 +7986,7 @@
               <a:buNone/>
             </a:pPr>
             <a:r>
-              <a:rPr lang="en-US" sz="2500" b="1" dirty="0">
+              <a:rPr lang="en-US" sz="1800" b="1" dirty="0">
                 <a:solidFill>
                   <a:srgbClr val="0F172A"/>
                 </a:solidFill>
@@ -9296,24 +7996,24 @@
               </a:rPr>
               <a:t>680만 원</a:t>
             </a:r>
-            <a:endParaRPr lang="en-US" sz="2500" dirty="0"/>
-          </a:p>
-        </p:txBody>
-      </p:sp>
-      <p:sp>
-        <p:nvSpPr>
-          <p:cNvPr id="23" name="Shape 21"/>
-          <p:cNvSpPr/>
-          <p:nvPr/>
-        </p:nvSpPr>
-        <p:spPr>
-          <a:xfrm>
-            <a:off x="7784287" y="6071616"/>
-            <a:ext cx="3840480" cy="1005840"/>
+            <a:endParaRPr lang="en-US" sz="1800" dirty="0"/>
+          </a:p>
+        </p:txBody>
+      </p:sp>
+      <p:sp>
+        <p:nvSpPr>
+          <p:cNvPr id="19" name="Shape 17"/>
+          <p:cNvSpPr/>
+          <p:nvPr/>
+        </p:nvSpPr>
+        <p:spPr>
+          <a:xfrm>
+            <a:off x="4307738" y="3319272"/>
+            <a:ext cx="3576218" cy="1051560"/>
           </a:xfrm>
           <a:prstGeom prst="roundRect">
             <a:avLst>
-              <a:gd name="adj" fmla="val 5455"/>
+              <a:gd name="adj" fmla="val 5217"/>
             </a:avLst>
           </a:prstGeom>
           <a:solidFill>
@@ -9329,14 +8029,14 @@
       </p:sp>
       <p:sp>
         <p:nvSpPr>
-          <p:cNvPr id="24" name="Text 22"/>
-          <p:cNvSpPr/>
-          <p:nvPr/>
-        </p:nvSpPr>
-        <p:spPr>
-          <a:xfrm>
-            <a:off x="7948879" y="6199632"/>
-            <a:ext cx="3511296" cy="201168"/>
+          <p:cNvPr id="20" name="Text 18"/>
+          <p:cNvSpPr/>
+          <p:nvPr/>
+        </p:nvSpPr>
+        <p:spPr>
+          <a:xfrm>
+            <a:off x="4472330" y="3447288"/>
+            <a:ext cx="3247034" cy="201168"/>
           </a:xfrm>
           <a:prstGeom prst="rect">
             <a:avLst/>
@@ -9368,14 +8068,14 @@
       </p:sp>
       <p:sp>
         <p:nvSpPr>
-          <p:cNvPr id="25" name="Text 23"/>
-          <p:cNvSpPr/>
-          <p:nvPr/>
-        </p:nvSpPr>
-        <p:spPr>
-          <a:xfrm>
-            <a:off x="7948879" y="6382512"/>
-            <a:ext cx="3511296" cy="402336"/>
+          <p:cNvPr id="21" name="Text 19"/>
+          <p:cNvSpPr/>
+          <p:nvPr/>
+        </p:nvSpPr>
+        <p:spPr>
+          <a:xfrm>
+            <a:off x="4472330" y="3630168"/>
+            <a:ext cx="3247034" cy="402336"/>
           </a:xfrm>
           <a:prstGeom prst="rect">
             <a:avLst/>
@@ -9393,7 +8093,7 @@
               <a:buNone/>
             </a:pPr>
             <a:r>
-              <a:rPr lang="en-US" sz="1400" b="1" dirty="0">
+              <a:rPr lang="en-US" sz="1800" b="1" dirty="0">
                 <a:solidFill>
                   <a:srgbClr val="0F172A"/>
                 </a:solidFill>
@@ -9403,24 +8103,24 @@
               </a:rPr>
               <a:t>5.82% (LTV 50% 실행 시)</a:t>
             </a:r>
-            <a:endParaRPr lang="en-US" sz="1400" dirty="0"/>
-          </a:p>
-        </p:txBody>
-      </p:sp>
-      <p:sp>
-        <p:nvSpPr>
-          <p:cNvPr id="26" name="Shape 24"/>
-          <p:cNvSpPr/>
-          <p:nvPr/>
-        </p:nvSpPr>
-        <p:spPr>
-          <a:xfrm>
-            <a:off x="7784287" y="7205472"/>
-            <a:ext cx="3840480" cy="1005840"/>
+            <a:endParaRPr lang="en-US" sz="1800" dirty="0"/>
+          </a:p>
+        </p:txBody>
+      </p:sp>
+      <p:sp>
+        <p:nvSpPr>
+          <p:cNvPr id="22" name="Shape 20"/>
+          <p:cNvSpPr/>
+          <p:nvPr/>
+        </p:nvSpPr>
+        <p:spPr>
+          <a:xfrm>
+            <a:off x="8048549" y="3319272"/>
+            <a:ext cx="3576218" cy="1051560"/>
           </a:xfrm>
           <a:prstGeom prst="roundRect">
             <a:avLst>
-              <a:gd name="adj" fmla="val 5455"/>
+              <a:gd name="adj" fmla="val 5217"/>
             </a:avLst>
           </a:prstGeom>
           <a:solidFill>
@@ -9436,14 +8136,14 @@
       </p:sp>
       <p:sp>
         <p:nvSpPr>
-          <p:cNvPr id="27" name="Text 25"/>
-          <p:cNvSpPr/>
-          <p:nvPr/>
-        </p:nvSpPr>
-        <p:spPr>
-          <a:xfrm>
-            <a:off x="7948879" y="7333488"/>
-            <a:ext cx="3511296" cy="201168"/>
+          <p:cNvPr id="23" name="Text 21"/>
+          <p:cNvSpPr/>
+          <p:nvPr/>
+        </p:nvSpPr>
+        <p:spPr>
+          <a:xfrm>
+            <a:off x="8213141" y="3447288"/>
+            <a:ext cx="3247034" cy="201168"/>
           </a:xfrm>
           <a:prstGeom prst="rect">
             <a:avLst/>
@@ -9475,14 +8175,14 @@
       </p:sp>
       <p:sp>
         <p:nvSpPr>
-          <p:cNvPr id="28" name="Text 26"/>
-          <p:cNvSpPr/>
-          <p:nvPr/>
-        </p:nvSpPr>
-        <p:spPr>
-          <a:xfrm>
-            <a:off x="7948879" y="7516368"/>
-            <a:ext cx="3511296" cy="402336"/>
+          <p:cNvPr id="24" name="Text 22"/>
+          <p:cNvSpPr/>
+          <p:nvPr/>
+        </p:nvSpPr>
+        <p:spPr>
+          <a:xfrm>
+            <a:off x="8213141" y="3630168"/>
+            <a:ext cx="3247034" cy="402336"/>
           </a:xfrm>
           <a:prstGeom prst="rect">
             <a:avLst/>
@@ -9500,7 +8200,7 @@
               <a:buNone/>
             </a:pPr>
             <a:r>
-              <a:rPr lang="en-US" sz="1100" b="1" dirty="0">
+              <a:rPr lang="en-US" sz="1800" b="1" dirty="0">
                 <a:solidFill>
                   <a:srgbClr val="0F172A"/>
                 </a:solidFill>
@@ -9510,20 +8210,62 @@
               </a:rPr>
               <a:t>약 68.5억 원 (보증금+대출 차감 후)</a:t>
             </a:r>
-            <a:endParaRPr lang="en-US" sz="1100" dirty="0"/>
-          </a:p>
-        </p:txBody>
-      </p:sp>
-      <p:sp>
-        <p:nvSpPr>
-          <p:cNvPr id="29" name="Text 27"/>
-          <p:cNvSpPr/>
-          <p:nvPr/>
-        </p:nvSpPr>
-        <p:spPr>
-          <a:xfrm>
-            <a:off x="566928" y="6419088"/>
-            <a:ext cx="11057839" cy="201168"/>
+            <a:endParaRPr lang="en-US" sz="1800" dirty="0"/>
+          </a:p>
+        </p:txBody>
+      </p:sp>
+      <p:sp>
+        <p:nvSpPr>
+          <p:cNvPr id="25" name="Shape 23"/>
+          <p:cNvSpPr/>
+          <p:nvPr/>
+        </p:nvSpPr>
+        <p:spPr>
+          <a:xfrm>
+            <a:off x="566928" y="4626864"/>
+            <a:ext cx="11057839" cy="1280160"/>
+          </a:xfrm>
+          <a:prstGeom prst="roundRect">
+            <a:avLst>
+              <a:gd name="adj" fmla="val 4286"/>
+            </a:avLst>
+          </a:prstGeom>
+          <a:solidFill>
+            <a:srgbClr val="DBEAFE"/>
+          </a:solidFill>
+          <a:ln/>
+        </p:spPr>
+      </p:sp>
+      <p:sp>
+        <p:nvSpPr>
+          <p:cNvPr id="26" name="Shape 24"/>
+          <p:cNvSpPr/>
+          <p:nvPr/>
+        </p:nvSpPr>
+        <p:spPr>
+          <a:xfrm>
+            <a:off x="566928" y="4681728"/>
+            <a:ext cx="36576" cy="1170432"/>
+          </a:xfrm>
+          <a:prstGeom prst="rect">
+            <a:avLst/>
+          </a:prstGeom>
+          <a:solidFill>
+            <a:srgbClr val="1D4ED8"/>
+          </a:solidFill>
+          <a:ln/>
+        </p:spPr>
+      </p:sp>
+      <p:sp>
+        <p:nvSpPr>
+          <p:cNvPr id="27" name="Text 25"/>
+          <p:cNvSpPr/>
+          <p:nvPr/>
+        </p:nvSpPr>
+        <p:spPr>
+          <a:xfrm>
+            <a:off x="749808" y="4736592"/>
+            <a:ext cx="10728655" cy="201168"/>
           </a:xfrm>
           <a:prstGeom prst="rect">
             <a:avLst/>
@@ -9535,18 +8277,99 @@
           <a:bodyPr wrap="square" lIns="0" tIns="0" rIns="0" bIns="0" rtlCol="0" anchor="ctr"/>
           <a:lstStyle/>
           <a:p>
-            <a:pPr algn="ctr" indent="0" marL="0">
-              <a:buNone/>
-            </a:pPr>
-            <a:r>
-              <a:rPr lang="en-US" sz="750" dirty="0">
-                <a:solidFill>
-                  <a:srgbClr val="64748B"/>
+            <a:pPr indent="0" marL="0">
+              <a:buNone/>
+            </a:pPr>
+            <a:r>
+              <a:rPr lang="en-US" sz="1050" b="1" dirty="0">
+                <a:solidFill>
+                  <a:srgbClr val="1D4ED8"/>
                 </a:solidFill>
                 <a:latin typeface="Pretendard" pitchFamily="34" charset="0"/>
                 <a:ea typeface="Pretendard" pitchFamily="34" charset="-122"/>
                 <a:cs typeface="Pretendard" pitchFamily="34" charset="-120"/>
               </a:rPr>
+              <a:t>투자 가치 제안</a:t>
+            </a:r>
+            <a:endParaRPr lang="en-US" sz="1050" dirty="0"/>
+          </a:p>
+        </p:txBody>
+      </p:sp>
+      <p:sp>
+        <p:nvSpPr>
+          <p:cNvPr id="28" name="Text 26"/>
+          <p:cNvSpPr/>
+          <p:nvPr/>
+        </p:nvSpPr>
+        <p:spPr>
+          <a:xfrm>
+            <a:off x="749808" y="4956048"/>
+            <a:ext cx="10728655" cy="877824"/>
+          </a:xfrm>
+          <a:prstGeom prst="rect">
+            <a:avLst/>
+          </a:prstGeom>
+          <a:noFill/>
+          <a:ln/>
+        </p:spPr>
+        <p:txBody>
+          <a:bodyPr wrap="square" lIns="0" tIns="0" rIns="0" bIns="0" rtlCol="0" anchor="t"/>
+          <a:lstStyle/>
+          <a:p>
+            <a:pPr indent="0" marL="0">
+              <a:lnSpc>
+                <a:spcPct val="120000"/>
+              </a:lnSpc>
+              <a:buNone/>
+            </a:pPr>
+            <a:r>
+              <a:rPr lang="en-US" sz="930" dirty="0">
+                <a:solidFill>
+                  <a:srgbClr val="0F172A"/>
+                </a:solidFill>
+                <a:latin typeface="Pretendard" pitchFamily="34" charset="0"/>
+                <a:ea typeface="Pretendard" pitchFamily="34" charset="-122"/>
+                <a:cs typeface="Pretendard" pitchFamily="34" charset="-120"/>
+              </a:rPr>
+              <a:t>본 자산은 우수한 입지 경쟁력과 견고한 펀더멘털을 바탕으로 안정적인 현금흐름 창출과 중장기 자산 가치 상승을 동시에 실현할 수 있는 우량 투자 기회입니다.</a:t>
+            </a:r>
+            <a:endParaRPr lang="en-US" sz="930" dirty="0"/>
+          </a:p>
+        </p:txBody>
+      </p:sp>
+      <p:sp>
+        <p:nvSpPr>
+          <p:cNvPr id="29" name="Text 27"/>
+          <p:cNvSpPr/>
+          <p:nvPr/>
+        </p:nvSpPr>
+        <p:spPr>
+          <a:xfrm>
+            <a:off x="566928" y="6419088"/>
+            <a:ext cx="11057839" cy="201168"/>
+          </a:xfrm>
+          <a:prstGeom prst="rect">
+            <a:avLst/>
+          </a:prstGeom>
+          <a:noFill/>
+          <a:ln/>
+        </p:spPr>
+        <p:txBody>
+          <a:bodyPr wrap="square" lIns="0" tIns="0" rIns="0" bIns="0" rtlCol="0" anchor="ctr"/>
+          <a:lstStyle/>
+          <a:p>
+            <a:pPr algn="ctr" indent="0" marL="0">
+              <a:buNone/>
+            </a:pPr>
+            <a:r>
+              <a:rPr lang="en-US" sz="750" dirty="0">
+                <a:solidFill>
+                  <a:srgbClr val="64748B"/>
+                </a:solidFill>
+                <a:latin typeface="Pretendard" pitchFamily="34" charset="0"/>
+                <a:ea typeface="Pretendard" pitchFamily="34" charset="-122"/>
+                <a:cs typeface="Pretendard" pitchFamily="34" charset="-120"/>
+              </a:rPr>
               <a:t>크리딜  ·    ·  6</a:t>
             </a:r>
             <a:endParaRPr lang="en-US" sz="750" dirty="0"/>
@@ -9570,7 +8393,7 @@
           <a:noFill/>
           <a:ln w="6350">
             <a:solidFill>
-              <a:srgbClr val="C8FF00"/>
+              <a:srgbClr val="6B8E00"/>
             </a:solidFill>
             <a:prstDash val="solid"/>
           </a:ln>
@@ -9623,7 +8446,7 @@
             <a:avLst/>
           </a:prstGeom>
           <a:solidFill>
-            <a:srgbClr val="C8FF00"/>
+            <a:srgbClr val="6B8E00"/>
           </a:solidFill>
           <a:ln/>
         </p:spPr>
@@ -9655,7 +8478,7 @@
             <a:r>
               <a:rPr lang="en-US" sz="950" b="1" spc="200" kern="0" dirty="0">
                 <a:solidFill>
-                  <a:srgbClr val="C8FF00"/>
+                  <a:srgbClr val="6B8E00"/>
                 </a:solidFill>
                 <a:latin typeface="Arial" pitchFamily="34" charset="0"/>
                 <a:ea typeface="Arial" pitchFamily="34" charset="-122"/>
@@ -9746,7 +8569,7 @@
             <a:avLst/>
           </a:prstGeom>
           <a:solidFill>
-            <a:srgbClr val="C8FF00"/>
+            <a:srgbClr val="6B8E00"/>
           </a:solidFill>
           <a:ln/>
         </p:spPr>
@@ -9766,7 +8589,7 @@
             <a:avLst/>
           </a:prstGeom>
           <a:solidFill>
-            <a:srgbClr val="C8FF00"/>
+            <a:srgbClr val="6B8E00"/>
           </a:solidFill>
           <a:ln/>
         </p:spPr>
@@ -9798,7 +8621,7 @@
             <a:r>
               <a:rPr lang="en-US" sz="1350" b="1" dirty="0">
                 <a:solidFill>
-                  <a:srgbClr val="A3D900"/>
+                  <a:srgbClr val="4F6A00"/>
                 </a:solidFill>
                 <a:latin typeface="Pretendard" pitchFamily="34" charset="0"/>
                 <a:ea typeface="Pretendard" pitchFamily="34" charset="-122"/>
@@ -9929,7 +8752,7 @@
             <a:avLst/>
           </a:prstGeom>
           <a:solidFill>
-            <a:srgbClr val="C8FF00"/>
+            <a:srgbClr val="6B8E00"/>
           </a:solidFill>
           <a:ln/>
         </p:spPr>
@@ -9949,7 +8772,7 @@
             <a:avLst/>
           </a:prstGeom>
           <a:solidFill>
-            <a:srgbClr val="C8FF00"/>
+            <a:srgbClr val="6B8E00"/>
           </a:solidFill>
           <a:ln/>
         </p:spPr>
@@ -9981,7 +8804,7 @@
             <a:r>
               <a:rPr lang="en-US" sz="1350" b="1" dirty="0">
                 <a:solidFill>
-                  <a:srgbClr val="A3D900"/>
+                  <a:srgbClr val="4F6A00"/>
                 </a:solidFill>
                 <a:latin typeface="Pretendard" pitchFamily="34" charset="0"/>
                 <a:ea typeface="Pretendard" pitchFamily="34" charset="-122"/>
@@ -10112,7 +8935,7 @@
             <a:avLst/>
           </a:prstGeom>
           <a:solidFill>
-            <a:srgbClr val="C8FF00"/>
+            <a:srgbClr val="6B8E00"/>
           </a:solidFill>
           <a:ln/>
         </p:spPr>
@@ -10132,7 +8955,7 @@
             <a:avLst/>
           </a:prstGeom>
           <a:solidFill>
-            <a:srgbClr val="C8FF00"/>
+            <a:srgbClr val="6B8E00"/>
           </a:solidFill>
           <a:ln/>
         </p:spPr>
@@ -10164,7 +8987,7 @@
             <a:r>
               <a:rPr lang="en-US" sz="1350" b="1" dirty="0">
                 <a:solidFill>
-                  <a:srgbClr val="A3D900"/>
+                  <a:srgbClr val="4F6A00"/>
                 </a:solidFill>
                 <a:latin typeface="Pretendard" pitchFamily="34" charset="0"/>
                 <a:ea typeface="Pretendard" pitchFamily="34" charset="-122"/>
@@ -10311,7 +9134,7 @@
           <a:noFill/>
           <a:ln w="6350">
             <a:solidFill>
-              <a:srgbClr val="C8FF00"/>
+              <a:srgbClr val="6B8E00"/>
             </a:solidFill>
             <a:prstDash val="solid"/>
           </a:ln>
@@ -10364,7 +9187,7 @@
             <a:avLst/>
           </a:prstGeom>
           <a:solidFill>
-            <a:srgbClr val="C8FF00"/>
+            <a:srgbClr val="6B8E00"/>
           </a:solidFill>
           <a:ln/>
         </p:spPr>
@@ -10396,7 +9219,7 @@
             <a:r>
               <a:rPr lang="en-US" sz="950" b="1" spc="200" kern="0" dirty="0">
                 <a:solidFill>
-                  <a:srgbClr val="C8FF00"/>
+                  <a:srgbClr val="6B8E00"/>
                 </a:solidFill>
                 <a:latin typeface="Arial" pitchFamily="34" charset="0"/>
                 <a:ea typeface="Arial" pitchFamily="34" charset="-122"/>
@@ -10528,7 +9351,7 @@
             <a:avLst/>
           </a:prstGeom>
           <a:solidFill>
-            <a:srgbClr val="C8FF00"/>
+            <a:srgbClr val="6B8E00"/>
           </a:solidFill>
           <a:ln/>
         </p:spPr>
@@ -10550,7 +9373,7 @@
             </a:avLst>
           </a:prstGeom>
           <a:solidFill>
-            <a:srgbClr val="E0FF66"/>
+            <a:srgbClr val="A3D900"/>
           </a:solidFill>
           <a:ln/>
         </p:spPr>
@@ -10582,7 +9405,7 @@
             <a:r>
               <a:rPr lang="en-US" sz="1000" b="1" dirty="0">
                 <a:solidFill>
-                  <a:srgbClr val="A3D900"/>
+                  <a:srgbClr val="4F6A00"/>
                 </a:solidFill>
                 <a:latin typeface="Arial" pitchFamily="34" charset="0"/>
                 <a:ea typeface="Arial" pitchFamily="34" charset="-122"/>
@@ -10717,7 +9540,7 @@
             <a:avLst/>
           </a:prstGeom>
           <a:solidFill>
-            <a:srgbClr val="C8FF00"/>
+            <a:srgbClr val="6B8E00"/>
           </a:solidFill>
           <a:ln/>
         </p:spPr>
@@ -10739,7 +9562,7 @@
             </a:avLst>
           </a:prstGeom>
           <a:solidFill>
-            <a:srgbClr val="E0FF66"/>
+            <a:srgbClr val="A3D900"/>
           </a:solidFill>
           <a:ln/>
         </p:spPr>
@@ -10771,7 +9594,7 @@
             <a:r>
               <a:rPr lang="en-US" sz="1000" b="1" dirty="0">
                 <a:solidFill>
-                  <a:srgbClr val="A3D900"/>
+                  <a:srgbClr val="4F6A00"/>
                 </a:solidFill>
                 <a:latin typeface="Arial" pitchFamily="34" charset="0"/>
                 <a:ea typeface="Arial" pitchFamily="34" charset="-122"/>
@@ -10906,7 +9729,7 @@
             <a:avLst/>
           </a:prstGeom>
           <a:solidFill>
-            <a:srgbClr val="C8FF00"/>
+            <a:srgbClr val="6B8E00"/>
           </a:solidFill>
           <a:ln/>
         </p:spPr>
@@ -10928,7 +9751,7 @@
             </a:avLst>
           </a:prstGeom>
           <a:solidFill>
-            <a:srgbClr val="E0FF66"/>
+            <a:srgbClr val="A3D900"/>
           </a:solidFill>
           <a:ln/>
         </p:spPr>
@@ -10960,7 +9783,7 @@
             <a:r>
               <a:rPr lang="en-US" sz="1000" b="1" dirty="0">
                 <a:solidFill>
-                  <a:srgbClr val="A3D900"/>
+                  <a:srgbClr val="4F6A00"/>
                 </a:solidFill>
                 <a:latin typeface="Arial" pitchFamily="34" charset="0"/>
                 <a:ea typeface="Arial" pitchFamily="34" charset="-122"/>
@@ -11095,7 +9918,7 @@
             <a:avLst/>
           </a:prstGeom>
           <a:solidFill>
-            <a:srgbClr val="C8FF00"/>
+            <a:srgbClr val="6B8E00"/>
           </a:solidFill>
           <a:ln/>
         </p:spPr>
@@ -11117,7 +9940,7 @@
             </a:avLst>
           </a:prstGeom>
           <a:solidFill>
-            <a:srgbClr val="E0FF66"/>
+            <a:srgbClr val="A3D900"/>
           </a:solidFill>
           <a:ln/>
         </p:spPr>
@@ -11149,7 +9972,7 @@
             <a:r>
               <a:rPr lang="en-US" sz="1000" b="1" dirty="0">
                 <a:solidFill>
-                  <a:srgbClr val="A3D900"/>
+                  <a:srgbClr val="4F6A00"/>
                 </a:solidFill>
                 <a:latin typeface="Arial" pitchFamily="34" charset="0"/>
                 <a:ea typeface="Arial" pitchFamily="34" charset="-122"/>
@@ -11259,11 +10082,11 @@
             </a:avLst>
           </a:prstGeom>
           <a:solidFill>
-            <a:srgbClr val="F5FFCC"/>
+            <a:srgbClr val="E8F5CC"/>
           </a:solidFill>
           <a:ln w="10160">
             <a:solidFill>
-              <a:srgbClr val="E0FF66"/>
+              <a:srgbClr val="A3D900"/>
             </a:solidFill>
             <a:prstDash val="solid"/>
           </a:ln>
@@ -11296,7 +10119,7 @@
             <a:r>
               <a:rPr lang="en-US" sz="950" b="1" dirty="0">
                 <a:solidFill>
-                  <a:srgbClr val="A3D900"/>
+                  <a:srgbClr val="4F6A00"/>
                 </a:solidFill>
                 <a:latin typeface="Pretendard" pitchFamily="34" charset="0"/>
                 <a:ea typeface="Pretendard" pitchFamily="34" charset="-122"/>
@@ -11406,7 +10229,7 @@
           <a:noFill/>
           <a:ln w="6350">
             <a:solidFill>
-              <a:srgbClr val="C8FF00"/>
+              <a:srgbClr val="6B8E00"/>
             </a:solidFill>
             <a:prstDash val="solid"/>
           </a:ln>
@@ -11426,7 +10249,7 @@
     <p:bg>
       <p:bgPr>
         <a:solidFill>
-          <a:srgbClr val="FFFFFF"/>
+          <a:srgbClr val="0F172A"/>
         </a:solidFill>
       </p:bgPr>
     </p:bg>
@@ -11459,7 +10282,7 @@
             <a:avLst/>
           </a:prstGeom>
           <a:solidFill>
-            <a:srgbClr val="C8FF00"/>
+            <a:srgbClr val="6B8E00"/>
           </a:solidFill>
           <a:ln/>
         </p:spPr>
@@ -11491,13 +10314,13 @@
             <a:r>
               <a:rPr lang="en-US" sz="950" b="1" spc="200" kern="0" dirty="0">
                 <a:solidFill>
-                  <a:srgbClr val="C8FF00"/>
+                  <a:srgbClr val="6B8E00"/>
                 </a:solidFill>
                 <a:latin typeface="Arial" pitchFamily="34" charset="0"/>
                 <a:ea typeface="Arial" pitchFamily="34" charset="-122"/>
                 <a:cs typeface="Arial" pitchFamily="34" charset="-120"/>
               </a:rPr>
-              <a:t>09  Process</a:t>
+              <a:t>09  Disclaimer</a:t>
             </a:r>
             <a:endParaRPr lang="en-US" sz="950" dirty="0"/>
           </a:p>
@@ -11530,7 +10353,7 @@
             <a:r>
               <a:rPr lang="en-US" sz="2200" b="1" dirty="0">
                 <a:solidFill>
-                  <a:srgbClr val="0F172A"/>
+                  <a:srgbClr val="FFFFFF"/>
                 </a:solidFill>
                 <a:latin typeface="Pretendard" pitchFamily="34" charset="0"/>
                 <a:ea typeface="Pretendard" pitchFamily="34" charset="-122"/>
@@ -11550,21 +10373,18 @@
         </p:nvSpPr>
         <p:spPr>
           <a:xfrm>
-            <a:off x="566928" y="1572768"/>
-            <a:ext cx="11057839" cy="3200400"/>
-          </a:xfrm>
-          <a:prstGeom prst="rect">
-            <a:avLst/>
+            <a:off x="566928" y="1463040"/>
+            <a:ext cx="3588410" cy="658368"/>
+          </a:xfrm>
+          <a:prstGeom prst="roundRect">
+            <a:avLst>
+              <a:gd name="adj" fmla="val 5556"/>
+            </a:avLst>
           </a:prstGeom>
           <a:solidFill>
-            <a:srgbClr val="F8FAFC"/>
+            <a:srgbClr val="334155"/>
           </a:solidFill>
-          <a:ln w="3810">
-            <a:solidFill>
-              <a:srgbClr val="CBD5E1"/>
-            </a:solidFill>
-            <a:prstDash val="solid"/>
-          </a:ln>
+          <a:ln/>
         </p:spPr>
       </p:sp>
       <p:sp>
@@ -11575,48 +10395,28 @@
         </p:nvSpPr>
         <p:spPr>
           <a:xfrm>
-            <a:off x="566928" y="1572768"/>
-            <a:ext cx="11057839" cy="36576"/>
-          </a:xfrm>
-          <a:prstGeom prst="rect">
+            <a:off x="676656" y="1572768"/>
+            <a:ext cx="438912" cy="438912"/>
+          </a:xfrm>
+          <a:prstGeom prst="ellipse">
             <a:avLst/>
           </a:prstGeom>
           <a:solidFill>
-            <a:srgbClr val="C8FF00"/>
+            <a:srgbClr val="6B8E00"/>
           </a:solidFill>
           <a:ln/>
         </p:spPr>
       </p:sp>
       <p:sp>
         <p:nvSpPr>
-          <p:cNvPr id="7" name="Shape 5"/>
-          <p:cNvSpPr/>
-          <p:nvPr/>
-        </p:nvSpPr>
-        <p:spPr>
-          <a:xfrm>
-            <a:off x="786384" y="1792224"/>
-            <a:ext cx="384048" cy="384048"/>
-          </a:xfrm>
-          <a:prstGeom prst="ellipse">
-            <a:avLst/>
-          </a:prstGeom>
-          <a:solidFill>
-            <a:srgbClr val="C8FF00"/>
-          </a:solidFill>
-          <a:ln/>
-        </p:spPr>
-      </p:sp>
-      <p:sp>
-        <p:nvSpPr>
-          <p:cNvPr id="8" name="Text 6"/>
-          <p:cNvSpPr/>
-          <p:nvPr/>
-        </p:nvSpPr>
-        <p:spPr>
-          <a:xfrm>
-            <a:off x="786384" y="1792224"/>
-            <a:ext cx="384048" cy="384048"/>
+          <p:cNvPr id="7" name="Text 5"/>
+          <p:cNvSpPr/>
+          <p:nvPr/>
+        </p:nvSpPr>
+        <p:spPr>
+          <a:xfrm>
+            <a:off x="676656" y="1572768"/>
+            <a:ext cx="438912" cy="438912"/>
           </a:xfrm>
           <a:prstGeom prst="rect">
             <a:avLst/>
@@ -11632,7 +10432,7 @@
               <a:buNone/>
             </a:pPr>
             <a:r>
-              <a:rPr lang="en-US" sz="1300" b="1" dirty="0">
+              <a:rPr lang="en-US" sz="1400" b="1" dirty="0">
                 <a:solidFill>
                   <a:srgbClr val="FFFFFF"/>
                 </a:solidFill>
@@ -11640,100 +10440,100 @@
                 <a:ea typeface="Arial" pitchFamily="34" charset="-122"/>
                 <a:cs typeface="Arial" pitchFamily="34" charset="-120"/>
               </a:rPr>
-              <a:t>STEP 1</a:t>
-            </a:r>
-            <a:endParaRPr lang="en-US" sz="1300" dirty="0"/>
-          </a:p>
-        </p:txBody>
-      </p:sp>
-      <p:sp>
-        <p:nvSpPr>
-          <p:cNvPr id="9" name="Text 7"/>
-          <p:cNvSpPr/>
-          <p:nvPr/>
-        </p:nvSpPr>
-        <p:spPr>
-          <a:xfrm>
-            <a:off x="786384" y="2304288"/>
-            <a:ext cx="10618927" cy="365760"/>
-          </a:xfrm>
-          <a:prstGeom prst="rect">
-            <a:avLst/>
-          </a:prstGeom>
-          <a:noFill/>
-          <a:ln/>
-        </p:spPr>
-        <p:txBody>
-          <a:bodyPr wrap="square" rtlCol="0" anchor="ctr"/>
+              <a:t>01</a:t>
+            </a:r>
+            <a:endParaRPr lang="en-US" sz="1400" dirty="0"/>
+          </a:p>
+        </p:txBody>
+      </p:sp>
+      <p:sp>
+        <p:nvSpPr>
+          <p:cNvPr id="8" name="Text 6"/>
+          <p:cNvSpPr/>
+          <p:nvPr/>
+        </p:nvSpPr>
+        <p:spPr>
+          <a:xfrm>
+            <a:off x="1225296" y="1554480"/>
+            <a:ext cx="2820314" cy="237744"/>
+          </a:xfrm>
+          <a:prstGeom prst="rect">
+            <a:avLst/>
+          </a:prstGeom>
+          <a:noFill/>
+          <a:ln/>
+        </p:spPr>
+        <p:txBody>
+          <a:bodyPr wrap="square" lIns="0" tIns="0" rIns="0" bIns="0" rtlCol="0" anchor="ctr"/>
           <a:lstStyle/>
           <a:p>
             <a:pPr indent="0" marL="0">
               <a:buNone/>
             </a:pPr>
             <a:r>
-              <a:rPr lang="en-US" sz="1600" b="1" dirty="0">
-                <a:solidFill>
-                  <a:srgbClr val="0F172A"/>
+              <a:rPr lang="en-US" sz="1100" b="1" dirty="0">
+                <a:solidFill>
+                  <a:srgbClr val="FFFFFF"/>
                 </a:solidFill>
                 <a:latin typeface="Pretendard" pitchFamily="34" charset="0"/>
                 <a:ea typeface="Pretendard" pitchFamily="34" charset="-122"/>
                 <a:cs typeface="Pretendard" pitchFamily="34" charset="-120"/>
               </a:rPr>
-              <a:t>본 자료는 매수 검토를 위한 요약 투자설명서이며, 세부</a:t>
-            </a:r>
-            <a:endParaRPr lang="en-US" sz="1600" dirty="0"/>
-          </a:p>
-        </p:txBody>
-      </p:sp>
-      <p:sp>
-        <p:nvSpPr>
-          <p:cNvPr id="10" name="Text 8"/>
-          <p:cNvSpPr/>
-          <p:nvPr/>
-        </p:nvSpPr>
-        <p:spPr>
-          <a:xfrm>
-            <a:off x="786384" y="2761488"/>
-            <a:ext cx="10618927" cy="1828800"/>
-          </a:xfrm>
-          <a:prstGeom prst="rect">
-            <a:avLst/>
-          </a:prstGeom>
-          <a:noFill/>
-          <a:ln/>
-        </p:spPr>
-        <p:txBody>
-          <a:bodyPr wrap="square" rtlCol="0" anchor="t"/>
+              <a:t>관심 표명</a:t>
+            </a:r>
+            <a:endParaRPr lang="en-US" sz="1100" dirty="0"/>
+          </a:p>
+        </p:txBody>
+      </p:sp>
+      <p:sp>
+        <p:nvSpPr>
+          <p:cNvPr id="9" name="Text 7"/>
+          <p:cNvSpPr/>
+          <p:nvPr/>
+        </p:nvSpPr>
+        <p:spPr>
+          <a:xfrm>
+            <a:off x="1225296" y="1792224"/>
+            <a:ext cx="2820314" cy="256032"/>
+          </a:xfrm>
+          <a:prstGeom prst="rect">
+            <a:avLst/>
+          </a:prstGeom>
+          <a:noFill/>
+          <a:ln/>
+        </p:spPr>
+        <p:txBody>
+          <a:bodyPr wrap="square" lIns="0" tIns="0" rIns="0" bIns="0" rtlCol="0" anchor="t"/>
           <a:lstStyle/>
           <a:p>
             <a:pPr indent="0" marL="0">
               <a:buNone/>
             </a:pPr>
             <a:r>
-              <a:rPr lang="en-US" sz="1100" dirty="0">
-                <a:solidFill>
-                  <a:srgbClr val="0F172A"/>
+              <a:rPr lang="en-US" sz="850" dirty="0">
+                <a:solidFill>
+                  <a:srgbClr val="94A3B8"/>
                 </a:solidFill>
                 <a:latin typeface="Pretendard" pitchFamily="34" charset="0"/>
                 <a:ea typeface="Pretendard" pitchFamily="34" charset="-122"/>
                 <a:cs typeface="Pretendard" pitchFamily="34" charset="-120"/>
               </a:rPr>
-              <a:t>본 자료는 매수 검토를 위한 요약 투자설명서이며, 세부 권리관계 및 계약서 원본은 실사 단계에서 제공됩니다.</a:t>
-            </a:r>
-            <a:endParaRPr lang="en-US" sz="1100" dirty="0"/>
-          </a:p>
-        </p:txBody>
-      </p:sp>
-      <p:sp>
-        <p:nvSpPr>
-          <p:cNvPr id="11" name="Text 9"/>
-          <p:cNvSpPr/>
-          <p:nvPr/>
-        </p:nvSpPr>
-        <p:spPr>
-          <a:xfrm>
-            <a:off x="566928" y="6419088"/>
-            <a:ext cx="11057839" cy="201168"/>
+              <a:t>담당 중개사에게 초기 관심 표명 및 상담 요청</a:t>
+            </a:r>
+            <a:endParaRPr lang="en-US" sz="850" dirty="0"/>
+          </a:p>
+        </p:txBody>
+      </p:sp>
+      <p:sp>
+        <p:nvSpPr>
+          <p:cNvPr id="10" name="Text 8"/>
+          <p:cNvSpPr/>
+          <p:nvPr/>
+        </p:nvSpPr>
+        <p:spPr>
+          <a:xfrm>
+            <a:off x="4155338" y="1600200"/>
+            <a:ext cx="146304" cy="384048"/>
           </a:xfrm>
           <a:prstGeom prst="rect">
             <a:avLst/>
@@ -11749,14 +10549,1111 @@
               <a:buNone/>
             </a:pPr>
             <a:r>
-              <a:rPr lang="en-US" sz="750" dirty="0">
-                <a:solidFill>
-                  <a:srgbClr val="64748B"/>
+              <a:rPr lang="en-US" sz="1600" dirty="0">
+                <a:solidFill>
+                  <a:srgbClr val="6B8E00"/>
                 </a:solidFill>
                 <a:latin typeface="Pretendard" pitchFamily="34" charset="0"/>
                 <a:ea typeface="Pretendard" pitchFamily="34" charset="-122"/>
                 <a:cs typeface="Pretendard" pitchFamily="34" charset="-120"/>
               </a:rPr>
+              <a:t>→</a:t>
+            </a:r>
+            <a:endParaRPr lang="en-US" sz="1600" dirty="0"/>
+          </a:p>
+        </p:txBody>
+      </p:sp>
+      <p:sp>
+        <p:nvSpPr>
+          <p:cNvPr id="11" name="Shape 9"/>
+          <p:cNvSpPr/>
+          <p:nvPr/>
+        </p:nvSpPr>
+        <p:spPr>
+          <a:xfrm>
+            <a:off x="4301642" y="1463040"/>
+            <a:ext cx="3588410" cy="658368"/>
+          </a:xfrm>
+          <a:prstGeom prst="roundRect">
+            <a:avLst>
+              <a:gd name="adj" fmla="val 5556"/>
+            </a:avLst>
+          </a:prstGeom>
+          <a:solidFill>
+            <a:srgbClr val="334155"/>
+          </a:solidFill>
+          <a:ln/>
+        </p:spPr>
+      </p:sp>
+      <p:sp>
+        <p:nvSpPr>
+          <p:cNvPr id="12" name="Shape 10"/>
+          <p:cNvSpPr/>
+          <p:nvPr/>
+        </p:nvSpPr>
+        <p:spPr>
+          <a:xfrm>
+            <a:off x="4411370" y="1572768"/>
+            <a:ext cx="438912" cy="438912"/>
+          </a:xfrm>
+          <a:prstGeom prst="ellipse">
+            <a:avLst/>
+          </a:prstGeom>
+          <a:solidFill>
+            <a:srgbClr val="6B8E00"/>
+          </a:solidFill>
+          <a:ln/>
+        </p:spPr>
+      </p:sp>
+      <p:sp>
+        <p:nvSpPr>
+          <p:cNvPr id="13" name="Text 11"/>
+          <p:cNvSpPr/>
+          <p:nvPr/>
+        </p:nvSpPr>
+        <p:spPr>
+          <a:xfrm>
+            <a:off x="4411370" y="1572768"/>
+            <a:ext cx="438912" cy="438912"/>
+          </a:xfrm>
+          <a:prstGeom prst="rect">
+            <a:avLst/>
+          </a:prstGeom>
+          <a:noFill/>
+          <a:ln/>
+        </p:spPr>
+        <p:txBody>
+          <a:bodyPr wrap="square" lIns="0" tIns="0" rIns="0" bIns="0" rtlCol="0" anchor="ctr"/>
+          <a:lstStyle/>
+          <a:p>
+            <a:pPr algn="ctr" indent="0" marL="0">
+              <a:buNone/>
+            </a:pPr>
+            <a:r>
+              <a:rPr lang="en-US" sz="1400" b="1" dirty="0">
+                <a:solidFill>
+                  <a:srgbClr val="FFFFFF"/>
+                </a:solidFill>
+                <a:latin typeface="Arial" pitchFamily="34" charset="0"/>
+                <a:ea typeface="Arial" pitchFamily="34" charset="-122"/>
+                <a:cs typeface="Arial" pitchFamily="34" charset="-120"/>
+              </a:rPr>
+              <a:t>02</a:t>
+            </a:r>
+            <a:endParaRPr lang="en-US" sz="1400" dirty="0"/>
+          </a:p>
+        </p:txBody>
+      </p:sp>
+      <p:sp>
+        <p:nvSpPr>
+          <p:cNvPr id="14" name="Text 12"/>
+          <p:cNvSpPr/>
+          <p:nvPr/>
+        </p:nvSpPr>
+        <p:spPr>
+          <a:xfrm>
+            <a:off x="4960010" y="1554480"/>
+            <a:ext cx="2820314" cy="237744"/>
+          </a:xfrm>
+          <a:prstGeom prst="rect">
+            <a:avLst/>
+          </a:prstGeom>
+          <a:noFill/>
+          <a:ln/>
+        </p:spPr>
+        <p:txBody>
+          <a:bodyPr wrap="square" lIns="0" tIns="0" rIns="0" bIns="0" rtlCol="0" anchor="ctr"/>
+          <a:lstStyle/>
+          <a:p>
+            <a:pPr indent="0" marL="0">
+              <a:buNone/>
+            </a:pPr>
+            <a:r>
+              <a:rPr lang="en-US" sz="1100" b="1" dirty="0">
+                <a:solidFill>
+                  <a:srgbClr val="FFFFFF"/>
+                </a:solidFill>
+                <a:latin typeface="Pretendard" pitchFamily="34" charset="0"/>
+                <a:ea typeface="Pretendard" pitchFamily="34" charset="-122"/>
+                <a:cs typeface="Pretendard" pitchFamily="34" charset="-120"/>
+              </a:rPr>
+              <a:t>NDA 체결</a:t>
+            </a:r>
+            <a:endParaRPr lang="en-US" sz="1100" dirty="0"/>
+          </a:p>
+        </p:txBody>
+      </p:sp>
+      <p:sp>
+        <p:nvSpPr>
+          <p:cNvPr id="15" name="Text 13"/>
+          <p:cNvSpPr/>
+          <p:nvPr/>
+        </p:nvSpPr>
+        <p:spPr>
+          <a:xfrm>
+            <a:off x="4960010" y="1792224"/>
+            <a:ext cx="2820314" cy="256032"/>
+          </a:xfrm>
+          <a:prstGeom prst="rect">
+            <a:avLst/>
+          </a:prstGeom>
+          <a:noFill/>
+          <a:ln/>
+        </p:spPr>
+        <p:txBody>
+          <a:bodyPr wrap="square" lIns="0" tIns="0" rIns="0" bIns="0" rtlCol="0" anchor="t"/>
+          <a:lstStyle/>
+          <a:p>
+            <a:pPr indent="0" marL="0">
+              <a:buNone/>
+            </a:pPr>
+            <a:r>
+              <a:rPr lang="en-US" sz="850" dirty="0">
+                <a:solidFill>
+                  <a:srgbClr val="94A3B8"/>
+                </a:solidFill>
+                <a:latin typeface="Pretendard" pitchFamily="34" charset="0"/>
+                <a:ea typeface="Pretendard" pitchFamily="34" charset="-122"/>
+                <a:cs typeface="Pretendard" pitchFamily="34" charset="-120"/>
+              </a:rPr>
+              <a:t>비밀유지계약 후 상세 임대차·재무 자료 제공</a:t>
+            </a:r>
+            <a:endParaRPr lang="en-US" sz="850" dirty="0"/>
+          </a:p>
+        </p:txBody>
+      </p:sp>
+      <p:sp>
+        <p:nvSpPr>
+          <p:cNvPr id="16" name="Text 14"/>
+          <p:cNvSpPr/>
+          <p:nvPr/>
+        </p:nvSpPr>
+        <p:spPr>
+          <a:xfrm>
+            <a:off x="7890053" y="1600200"/>
+            <a:ext cx="146304" cy="384048"/>
+          </a:xfrm>
+          <a:prstGeom prst="rect">
+            <a:avLst/>
+          </a:prstGeom>
+          <a:noFill/>
+          <a:ln/>
+        </p:spPr>
+        <p:txBody>
+          <a:bodyPr wrap="square" lIns="0" tIns="0" rIns="0" bIns="0" rtlCol="0" anchor="ctr"/>
+          <a:lstStyle/>
+          <a:p>
+            <a:pPr algn="ctr" indent="0" marL="0">
+              <a:buNone/>
+            </a:pPr>
+            <a:r>
+              <a:rPr lang="en-US" sz="1600" dirty="0">
+                <a:solidFill>
+                  <a:srgbClr val="6B8E00"/>
+                </a:solidFill>
+                <a:latin typeface="Pretendard" pitchFamily="34" charset="0"/>
+                <a:ea typeface="Pretendard" pitchFamily="34" charset="-122"/>
+                <a:cs typeface="Pretendard" pitchFamily="34" charset="-120"/>
+              </a:rPr>
+              <a:t>→</a:t>
+            </a:r>
+            <a:endParaRPr lang="en-US" sz="1600" dirty="0"/>
+          </a:p>
+        </p:txBody>
+      </p:sp>
+      <p:sp>
+        <p:nvSpPr>
+          <p:cNvPr id="17" name="Shape 15"/>
+          <p:cNvSpPr/>
+          <p:nvPr/>
+        </p:nvSpPr>
+        <p:spPr>
+          <a:xfrm>
+            <a:off x="8036357" y="1463040"/>
+            <a:ext cx="3588410" cy="658368"/>
+          </a:xfrm>
+          <a:prstGeom prst="roundRect">
+            <a:avLst>
+              <a:gd name="adj" fmla="val 5556"/>
+            </a:avLst>
+          </a:prstGeom>
+          <a:solidFill>
+            <a:srgbClr val="334155"/>
+          </a:solidFill>
+          <a:ln/>
+        </p:spPr>
+      </p:sp>
+      <p:sp>
+        <p:nvSpPr>
+          <p:cNvPr id="18" name="Shape 16"/>
+          <p:cNvSpPr/>
+          <p:nvPr/>
+        </p:nvSpPr>
+        <p:spPr>
+          <a:xfrm>
+            <a:off x="8146085" y="1572768"/>
+            <a:ext cx="438912" cy="438912"/>
+          </a:xfrm>
+          <a:prstGeom prst="ellipse">
+            <a:avLst/>
+          </a:prstGeom>
+          <a:solidFill>
+            <a:srgbClr val="6B8E00"/>
+          </a:solidFill>
+          <a:ln/>
+        </p:spPr>
+      </p:sp>
+      <p:sp>
+        <p:nvSpPr>
+          <p:cNvPr id="19" name="Text 17"/>
+          <p:cNvSpPr/>
+          <p:nvPr/>
+        </p:nvSpPr>
+        <p:spPr>
+          <a:xfrm>
+            <a:off x="8146085" y="1572768"/>
+            <a:ext cx="438912" cy="438912"/>
+          </a:xfrm>
+          <a:prstGeom prst="rect">
+            <a:avLst/>
+          </a:prstGeom>
+          <a:noFill/>
+          <a:ln/>
+        </p:spPr>
+        <p:txBody>
+          <a:bodyPr wrap="square" lIns="0" tIns="0" rIns="0" bIns="0" rtlCol="0" anchor="ctr"/>
+          <a:lstStyle/>
+          <a:p>
+            <a:pPr algn="ctr" indent="0" marL="0">
+              <a:buNone/>
+            </a:pPr>
+            <a:r>
+              <a:rPr lang="en-US" sz="1400" b="1" dirty="0">
+                <a:solidFill>
+                  <a:srgbClr val="FFFFFF"/>
+                </a:solidFill>
+                <a:latin typeface="Arial" pitchFamily="34" charset="0"/>
+                <a:ea typeface="Arial" pitchFamily="34" charset="-122"/>
+                <a:cs typeface="Arial" pitchFamily="34" charset="-120"/>
+              </a:rPr>
+              <a:t>03</a:t>
+            </a:r>
+            <a:endParaRPr lang="en-US" sz="1400" dirty="0"/>
+          </a:p>
+        </p:txBody>
+      </p:sp>
+      <p:sp>
+        <p:nvSpPr>
+          <p:cNvPr id="20" name="Text 18"/>
+          <p:cNvSpPr/>
+          <p:nvPr/>
+        </p:nvSpPr>
+        <p:spPr>
+          <a:xfrm>
+            <a:off x="8694725" y="1554480"/>
+            <a:ext cx="2820314" cy="237744"/>
+          </a:xfrm>
+          <a:prstGeom prst="rect">
+            <a:avLst/>
+          </a:prstGeom>
+          <a:noFill/>
+          <a:ln/>
+        </p:spPr>
+        <p:txBody>
+          <a:bodyPr wrap="square" lIns="0" tIns="0" rIns="0" bIns="0" rtlCol="0" anchor="ctr"/>
+          <a:lstStyle/>
+          <a:p>
+            <a:pPr indent="0" marL="0">
+              <a:buNone/>
+            </a:pPr>
+            <a:r>
+              <a:rPr lang="en-US" sz="1100" b="1" dirty="0">
+                <a:solidFill>
+                  <a:srgbClr val="FFFFFF"/>
+                </a:solidFill>
+                <a:latin typeface="Pretendard" pitchFamily="34" charset="0"/>
+                <a:ea typeface="Pretendard" pitchFamily="34" charset="-122"/>
+                <a:cs typeface="Pretendard" pitchFamily="34" charset="-120"/>
+              </a:rPr>
+              <a:t>현장 실사</a:t>
+            </a:r>
+            <a:endParaRPr lang="en-US" sz="1100" dirty="0"/>
+          </a:p>
+        </p:txBody>
+      </p:sp>
+      <p:sp>
+        <p:nvSpPr>
+          <p:cNvPr id="21" name="Text 19"/>
+          <p:cNvSpPr/>
+          <p:nvPr/>
+        </p:nvSpPr>
+        <p:spPr>
+          <a:xfrm>
+            <a:off x="8694725" y="1792224"/>
+            <a:ext cx="2820314" cy="256032"/>
+          </a:xfrm>
+          <a:prstGeom prst="rect">
+            <a:avLst/>
+          </a:prstGeom>
+          <a:noFill/>
+          <a:ln/>
+        </p:spPr>
+        <p:txBody>
+          <a:bodyPr wrap="square" lIns="0" tIns="0" rIns="0" bIns="0" rtlCol="0" anchor="t"/>
+          <a:lstStyle/>
+          <a:p>
+            <a:pPr indent="0" marL="0">
+              <a:buNone/>
+            </a:pPr>
+            <a:r>
+              <a:rPr lang="en-US" sz="850" dirty="0">
+                <a:solidFill>
+                  <a:srgbClr val="94A3B8"/>
+                </a:solidFill>
+                <a:latin typeface="Pretendard" pitchFamily="34" charset="0"/>
+                <a:ea typeface="Pretendard" pitchFamily="34" charset="-122"/>
+                <a:cs typeface="Pretendard" pitchFamily="34" charset="-120"/>
+              </a:rPr>
+              <a:t>건물 컨디션 및 설비 직접 확인 후 의향서(LOI) 제출</a:t>
+            </a:r>
+            <a:endParaRPr lang="en-US" sz="850" dirty="0"/>
+          </a:p>
+        </p:txBody>
+      </p:sp>
+      <p:sp>
+        <p:nvSpPr>
+          <p:cNvPr id="22" name="Text 20"/>
+          <p:cNvSpPr/>
+          <p:nvPr/>
+        </p:nvSpPr>
+        <p:spPr>
+          <a:xfrm>
+            <a:off x="566928" y="2395728"/>
+            <a:ext cx="5486400" cy="237744"/>
+          </a:xfrm>
+          <a:prstGeom prst="rect">
+            <a:avLst/>
+          </a:prstGeom>
+          <a:noFill/>
+          <a:ln/>
+        </p:spPr>
+        <p:txBody>
+          <a:bodyPr wrap="square" lIns="0" tIns="0" rIns="0" bIns="0" rtlCol="0" anchor="ctr"/>
+          <a:lstStyle/>
+          <a:p>
+            <a:pPr indent="0" marL="0">
+              <a:buNone/>
+            </a:pPr>
+            <a:r>
+              <a:rPr lang="en-US" sz="1100" b="1" dirty="0">
+                <a:solidFill>
+                  <a:srgbClr val="FFFFFF"/>
+                </a:solidFill>
+                <a:latin typeface="Pretendard" pitchFamily="34" charset="0"/>
+                <a:ea typeface="Pretendard" pitchFamily="34" charset="-122"/>
+                <a:cs typeface="Pretendard" pitchFamily="34" charset="-120"/>
+              </a:rPr>
+              <a:t>데이터 출처 표기</a:t>
+            </a:r>
+            <a:endParaRPr lang="en-US" sz="1100" dirty="0"/>
+          </a:p>
+        </p:txBody>
+      </p:sp>
+      <p:sp>
+        <p:nvSpPr>
+          <p:cNvPr id="23" name="Shape 21"/>
+          <p:cNvSpPr/>
+          <p:nvPr/>
+        </p:nvSpPr>
+        <p:spPr>
+          <a:xfrm>
+            <a:off x="566928" y="2724912"/>
+            <a:ext cx="1280160" cy="292608"/>
+          </a:xfrm>
+          <a:prstGeom prst="roundRect">
+            <a:avLst>
+              <a:gd name="adj" fmla="val 12500"/>
+            </a:avLst>
+          </a:prstGeom>
+          <a:solidFill>
+            <a:srgbClr val="334155"/>
+          </a:solidFill>
+          <a:ln/>
+        </p:spPr>
+      </p:sp>
+      <p:sp>
+        <p:nvSpPr>
+          <p:cNvPr id="24" name="Text 22"/>
+          <p:cNvSpPr/>
+          <p:nvPr/>
+        </p:nvSpPr>
+        <p:spPr>
+          <a:xfrm>
+            <a:off x="566928" y="2724912"/>
+            <a:ext cx="1280160" cy="292608"/>
+          </a:xfrm>
+          <a:prstGeom prst="rect">
+            <a:avLst/>
+          </a:prstGeom>
+          <a:noFill/>
+          <a:ln/>
+        </p:spPr>
+        <p:txBody>
+          <a:bodyPr wrap="square" lIns="0" tIns="0" rIns="0" bIns="0" rtlCol="0" anchor="ctr"/>
+          <a:lstStyle/>
+          <a:p>
+            <a:pPr algn="ctr" indent="0" marL="0">
+              <a:buNone/>
+            </a:pPr>
+            <a:r>
+              <a:rPr lang="en-US" sz="850" b="1" dirty="0">
+                <a:solidFill>
+                  <a:srgbClr val="FFFFFF"/>
+                </a:solidFill>
+                <a:latin typeface="Pretendard" pitchFamily="34" charset="0"/>
+                <a:ea typeface="Pretendard" pitchFamily="34" charset="-122"/>
+                <a:cs typeface="Pretendard" pitchFamily="34" charset="-120"/>
+              </a:rPr>
+              <a:t>✓ 공부확인</a:t>
+            </a:r>
+            <a:endParaRPr lang="en-US" sz="850" dirty="0"/>
+          </a:p>
+        </p:txBody>
+      </p:sp>
+      <p:sp>
+        <p:nvSpPr>
+          <p:cNvPr id="25" name="Text 23"/>
+          <p:cNvSpPr/>
+          <p:nvPr/>
+        </p:nvSpPr>
+        <p:spPr>
+          <a:xfrm>
+            <a:off x="1993392" y="2706624"/>
+            <a:ext cx="3840480" cy="329184"/>
+          </a:xfrm>
+          <a:prstGeom prst="rect">
+            <a:avLst/>
+          </a:prstGeom>
+          <a:noFill/>
+          <a:ln/>
+        </p:spPr>
+        <p:txBody>
+          <a:bodyPr wrap="square" lIns="0" tIns="0" rIns="0" bIns="0" rtlCol="0" anchor="ctr"/>
+          <a:lstStyle/>
+          <a:p>
+            <a:pPr indent="0" marL="0">
+              <a:buNone/>
+            </a:pPr>
+            <a:r>
+              <a:rPr lang="en-US" sz="900" dirty="0">
+                <a:solidFill>
+                  <a:srgbClr val="F1F5F9"/>
+                </a:solidFill>
+                <a:latin typeface="Pretendard" pitchFamily="34" charset="0"/>
+                <a:ea typeface="Pretendard" pitchFamily="34" charset="-122"/>
+                <a:cs typeface="Pretendard" pitchFamily="34" charset="-120"/>
+              </a:rPr>
+              <a:t>등기부·대장 등 공적 장부 직접 확인</a:t>
+            </a:r>
+            <a:endParaRPr lang="en-US" sz="900" dirty="0"/>
+          </a:p>
+        </p:txBody>
+      </p:sp>
+      <p:sp>
+        <p:nvSpPr>
+          <p:cNvPr id="26" name="Shape 24"/>
+          <p:cNvSpPr/>
+          <p:nvPr/>
+        </p:nvSpPr>
+        <p:spPr>
+          <a:xfrm>
+            <a:off x="566928" y="3200400"/>
+            <a:ext cx="1280160" cy="292608"/>
+          </a:xfrm>
+          <a:prstGeom prst="roundRect">
+            <a:avLst>
+              <a:gd name="adj" fmla="val 12500"/>
+            </a:avLst>
+          </a:prstGeom>
+          <a:solidFill>
+            <a:srgbClr val="334155"/>
+          </a:solidFill>
+          <a:ln/>
+        </p:spPr>
+      </p:sp>
+      <p:sp>
+        <p:nvSpPr>
+          <p:cNvPr id="27" name="Text 25"/>
+          <p:cNvSpPr/>
+          <p:nvPr/>
+        </p:nvSpPr>
+        <p:spPr>
+          <a:xfrm>
+            <a:off x="566928" y="3200400"/>
+            <a:ext cx="1280160" cy="292608"/>
+          </a:xfrm>
+          <a:prstGeom prst="rect">
+            <a:avLst/>
+          </a:prstGeom>
+          <a:noFill/>
+          <a:ln/>
+        </p:spPr>
+        <p:txBody>
+          <a:bodyPr wrap="square" lIns="0" tIns="0" rIns="0" bIns="0" rtlCol="0" anchor="ctr"/>
+          <a:lstStyle/>
+          <a:p>
+            <a:pPr algn="ctr" indent="0" marL="0">
+              <a:buNone/>
+            </a:pPr>
+            <a:r>
+              <a:rPr lang="en-US" sz="850" b="1" dirty="0">
+                <a:solidFill>
+                  <a:srgbClr val="FFFFFF"/>
+                </a:solidFill>
+                <a:latin typeface="Pretendard" pitchFamily="34" charset="0"/>
+                <a:ea typeface="Pretendard" pitchFamily="34" charset="-122"/>
+                <a:cs typeface="Pretendard" pitchFamily="34" charset="-120"/>
+              </a:rPr>
+              <a:t>★ 전문가검증</a:t>
+            </a:r>
+            <a:endParaRPr lang="en-US" sz="850" dirty="0"/>
+          </a:p>
+        </p:txBody>
+      </p:sp>
+      <p:sp>
+        <p:nvSpPr>
+          <p:cNvPr id="28" name="Text 26"/>
+          <p:cNvSpPr/>
+          <p:nvPr/>
+        </p:nvSpPr>
+        <p:spPr>
+          <a:xfrm>
+            <a:off x="1993392" y="3182112"/>
+            <a:ext cx="3840480" cy="329184"/>
+          </a:xfrm>
+          <a:prstGeom prst="rect">
+            <a:avLst/>
+          </a:prstGeom>
+          <a:noFill/>
+          <a:ln/>
+        </p:spPr>
+        <p:txBody>
+          <a:bodyPr wrap="square" lIns="0" tIns="0" rIns="0" bIns="0" rtlCol="0" anchor="ctr"/>
+          <a:lstStyle/>
+          <a:p>
+            <a:pPr indent="0" marL="0">
+              <a:buNone/>
+            </a:pPr>
+            <a:r>
+              <a:rPr lang="en-US" sz="900" dirty="0">
+                <a:solidFill>
+                  <a:srgbClr val="F1F5F9"/>
+                </a:solidFill>
+                <a:latin typeface="Pretendard" pitchFamily="34" charset="0"/>
+                <a:ea typeface="Pretendard" pitchFamily="34" charset="-122"/>
+                <a:cs typeface="Pretendard" pitchFamily="34" charset="-120"/>
+              </a:rPr>
+              <a:t>세무사·감정평가사 등 전문가 확인</a:t>
+            </a:r>
+            <a:endParaRPr lang="en-US" sz="900" dirty="0"/>
+          </a:p>
+        </p:txBody>
+      </p:sp>
+      <p:sp>
+        <p:nvSpPr>
+          <p:cNvPr id="29" name="Shape 27"/>
+          <p:cNvSpPr/>
+          <p:nvPr/>
+        </p:nvSpPr>
+        <p:spPr>
+          <a:xfrm>
+            <a:off x="566928" y="3675888"/>
+            <a:ext cx="1280160" cy="292608"/>
+          </a:xfrm>
+          <a:prstGeom prst="roundRect">
+            <a:avLst>
+              <a:gd name="adj" fmla="val 12500"/>
+            </a:avLst>
+          </a:prstGeom>
+          <a:solidFill>
+            <a:srgbClr val="334155"/>
+          </a:solidFill>
+          <a:ln/>
+        </p:spPr>
+      </p:sp>
+      <p:sp>
+        <p:nvSpPr>
+          <p:cNvPr id="30" name="Text 28"/>
+          <p:cNvSpPr/>
+          <p:nvPr/>
+        </p:nvSpPr>
+        <p:spPr>
+          <a:xfrm>
+            <a:off x="566928" y="3675888"/>
+            <a:ext cx="1280160" cy="292608"/>
+          </a:xfrm>
+          <a:prstGeom prst="rect">
+            <a:avLst/>
+          </a:prstGeom>
+          <a:noFill/>
+          <a:ln/>
+        </p:spPr>
+        <p:txBody>
+          <a:bodyPr wrap="square" lIns="0" tIns="0" rIns="0" bIns="0" rtlCol="0" anchor="ctr"/>
+          <a:lstStyle/>
+          <a:p>
+            <a:pPr algn="ctr" indent="0" marL="0">
+              <a:buNone/>
+            </a:pPr>
+            <a:r>
+              <a:rPr lang="en-US" sz="850" b="1" dirty="0">
+                <a:solidFill>
+                  <a:srgbClr val="FFFFFF"/>
+                </a:solidFill>
+                <a:latin typeface="Pretendard" pitchFamily="34" charset="0"/>
+                <a:ea typeface="Pretendard" pitchFamily="34" charset="-122"/>
+                <a:cs typeface="Pretendard" pitchFamily="34" charset="-120"/>
+              </a:rPr>
+              <a:t>▲ 매도인고지</a:t>
+            </a:r>
+            <a:endParaRPr lang="en-US" sz="850" dirty="0"/>
+          </a:p>
+        </p:txBody>
+      </p:sp>
+      <p:sp>
+        <p:nvSpPr>
+          <p:cNvPr id="31" name="Text 29"/>
+          <p:cNvSpPr/>
+          <p:nvPr/>
+        </p:nvSpPr>
+        <p:spPr>
+          <a:xfrm>
+            <a:off x="1993392" y="3657600"/>
+            <a:ext cx="3840480" cy="329184"/>
+          </a:xfrm>
+          <a:prstGeom prst="rect">
+            <a:avLst/>
+          </a:prstGeom>
+          <a:noFill/>
+          <a:ln/>
+        </p:spPr>
+        <p:txBody>
+          <a:bodyPr wrap="square" lIns="0" tIns="0" rIns="0" bIns="0" rtlCol="0" anchor="ctr"/>
+          <a:lstStyle/>
+          <a:p>
+            <a:pPr indent="0" marL="0">
+              <a:buNone/>
+            </a:pPr>
+            <a:r>
+              <a:rPr lang="en-US" sz="900" dirty="0">
+                <a:solidFill>
+                  <a:srgbClr val="F1F5F9"/>
+                </a:solidFill>
+                <a:latin typeface="Pretendard" pitchFamily="34" charset="0"/>
+                <a:ea typeface="Pretendard" pitchFamily="34" charset="-122"/>
+                <a:cs typeface="Pretendard" pitchFamily="34" charset="-120"/>
+              </a:rPr>
+              <a:t>매도인이 구두 또는 서면으로 고지</a:t>
+            </a:r>
+            <a:endParaRPr lang="en-US" sz="900" dirty="0"/>
+          </a:p>
+        </p:txBody>
+      </p:sp>
+      <p:sp>
+        <p:nvSpPr>
+          <p:cNvPr id="32" name="Shape 30"/>
+          <p:cNvSpPr/>
+          <p:nvPr/>
+        </p:nvSpPr>
+        <p:spPr>
+          <a:xfrm>
+            <a:off x="566928" y="4151376"/>
+            <a:ext cx="1280160" cy="292608"/>
+          </a:xfrm>
+          <a:prstGeom prst="roundRect">
+            <a:avLst>
+              <a:gd name="adj" fmla="val 12500"/>
+            </a:avLst>
+          </a:prstGeom>
+          <a:solidFill>
+            <a:srgbClr val="334155"/>
+          </a:solidFill>
+          <a:ln/>
+        </p:spPr>
+      </p:sp>
+      <p:sp>
+        <p:nvSpPr>
+          <p:cNvPr id="33" name="Text 31"/>
+          <p:cNvSpPr/>
+          <p:nvPr/>
+        </p:nvSpPr>
+        <p:spPr>
+          <a:xfrm>
+            <a:off x="566928" y="4151376"/>
+            <a:ext cx="1280160" cy="292608"/>
+          </a:xfrm>
+          <a:prstGeom prst="rect">
+            <a:avLst/>
+          </a:prstGeom>
+          <a:noFill/>
+          <a:ln/>
+        </p:spPr>
+        <p:txBody>
+          <a:bodyPr wrap="square" lIns="0" tIns="0" rIns="0" bIns="0" rtlCol="0" anchor="ctr"/>
+          <a:lstStyle/>
+          <a:p>
+            <a:pPr algn="ctr" indent="0" marL="0">
+              <a:buNone/>
+            </a:pPr>
+            <a:r>
+              <a:rPr lang="en-US" sz="850" b="1" dirty="0">
+                <a:solidFill>
+                  <a:srgbClr val="FFFFFF"/>
+                </a:solidFill>
+                <a:latin typeface="Pretendard" pitchFamily="34" charset="0"/>
+                <a:ea typeface="Pretendard" pitchFamily="34" charset="-122"/>
+                <a:cs typeface="Pretendard" pitchFamily="34" charset="-120"/>
+              </a:rPr>
+              <a:t>● 중개인입력</a:t>
+            </a:r>
+            <a:endParaRPr lang="en-US" sz="850" dirty="0"/>
+          </a:p>
+        </p:txBody>
+      </p:sp>
+      <p:sp>
+        <p:nvSpPr>
+          <p:cNvPr id="34" name="Text 32"/>
+          <p:cNvSpPr/>
+          <p:nvPr/>
+        </p:nvSpPr>
+        <p:spPr>
+          <a:xfrm>
+            <a:off x="1993392" y="4133088"/>
+            <a:ext cx="3840480" cy="329184"/>
+          </a:xfrm>
+          <a:prstGeom prst="rect">
+            <a:avLst/>
+          </a:prstGeom>
+          <a:noFill/>
+          <a:ln/>
+        </p:spPr>
+        <p:txBody>
+          <a:bodyPr wrap="square" lIns="0" tIns="0" rIns="0" bIns="0" rtlCol="0" anchor="ctr"/>
+          <a:lstStyle/>
+          <a:p>
+            <a:pPr indent="0" marL="0">
+              <a:buNone/>
+            </a:pPr>
+            <a:r>
+              <a:rPr lang="en-US" sz="900" dirty="0">
+                <a:solidFill>
+                  <a:srgbClr val="F1F5F9"/>
+                </a:solidFill>
+                <a:latin typeface="Pretendard" pitchFamily="34" charset="0"/>
+                <a:ea typeface="Pretendard" pitchFamily="34" charset="-122"/>
+                <a:cs typeface="Pretendard" pitchFamily="34" charset="-120"/>
+              </a:rPr>
+              <a:t>중개인 현장 조사 및 경험 기반 입력</a:t>
+            </a:r>
+            <a:endParaRPr lang="en-US" sz="900" dirty="0"/>
+          </a:p>
+        </p:txBody>
+      </p:sp>
+      <p:sp>
+        <p:nvSpPr>
+          <p:cNvPr id="35" name="Shape 33"/>
+          <p:cNvSpPr/>
+          <p:nvPr/>
+        </p:nvSpPr>
+        <p:spPr>
+          <a:xfrm>
+            <a:off x="566928" y="4626864"/>
+            <a:ext cx="1280160" cy="292608"/>
+          </a:xfrm>
+          <a:prstGeom prst="roundRect">
+            <a:avLst>
+              <a:gd name="adj" fmla="val 12500"/>
+            </a:avLst>
+          </a:prstGeom>
+          <a:solidFill>
+            <a:srgbClr val="334155"/>
+          </a:solidFill>
+          <a:ln/>
+        </p:spPr>
+      </p:sp>
+      <p:sp>
+        <p:nvSpPr>
+          <p:cNvPr id="36" name="Text 34"/>
+          <p:cNvSpPr/>
+          <p:nvPr/>
+        </p:nvSpPr>
+        <p:spPr>
+          <a:xfrm>
+            <a:off x="566928" y="4626864"/>
+            <a:ext cx="1280160" cy="292608"/>
+          </a:xfrm>
+          <a:prstGeom prst="rect">
+            <a:avLst/>
+          </a:prstGeom>
+          <a:noFill/>
+          <a:ln/>
+        </p:spPr>
+        <p:txBody>
+          <a:bodyPr wrap="square" lIns="0" tIns="0" rIns="0" bIns="0" rtlCol="0" anchor="ctr"/>
+          <a:lstStyle/>
+          <a:p>
+            <a:pPr algn="ctr" indent="0" marL="0">
+              <a:buNone/>
+            </a:pPr>
+            <a:r>
+              <a:rPr lang="en-US" sz="850" b="1" dirty="0">
+                <a:solidFill>
+                  <a:srgbClr val="FFFFFF"/>
+                </a:solidFill>
+                <a:latin typeface="Pretendard" pitchFamily="34" charset="0"/>
+                <a:ea typeface="Pretendard" pitchFamily="34" charset="-122"/>
+                <a:cs typeface="Pretendard" pitchFamily="34" charset="-120"/>
+              </a:rPr>
+              <a:t>◇ AI추정·가정</a:t>
+            </a:r>
+            <a:endParaRPr lang="en-US" sz="850" dirty="0"/>
+          </a:p>
+        </p:txBody>
+      </p:sp>
+      <p:sp>
+        <p:nvSpPr>
+          <p:cNvPr id="37" name="Text 35"/>
+          <p:cNvSpPr/>
+          <p:nvPr/>
+        </p:nvSpPr>
+        <p:spPr>
+          <a:xfrm>
+            <a:off x="1993392" y="4608576"/>
+            <a:ext cx="3840480" cy="329184"/>
+          </a:xfrm>
+          <a:prstGeom prst="rect">
+            <a:avLst/>
+          </a:prstGeom>
+          <a:noFill/>
+          <a:ln/>
+        </p:spPr>
+        <p:txBody>
+          <a:bodyPr wrap="square" lIns="0" tIns="0" rIns="0" bIns="0" rtlCol="0" anchor="ctr"/>
+          <a:lstStyle/>
+          <a:p>
+            <a:pPr indent="0" marL="0">
+              <a:buNone/>
+            </a:pPr>
+            <a:r>
+              <a:rPr lang="en-US" sz="900" dirty="0">
+                <a:solidFill>
+                  <a:srgbClr val="F1F5F9"/>
+                </a:solidFill>
+                <a:latin typeface="Pretendard" pitchFamily="34" charset="0"/>
+                <a:ea typeface="Pretendard" pitchFamily="34" charset="-122"/>
+                <a:cs typeface="Pretendard" pitchFamily="34" charset="-120"/>
+              </a:rPr>
+              <a:t>시나리오 분석 및 AI 모델 추정</a:t>
+            </a:r>
+            <a:endParaRPr lang="en-US" sz="900" dirty="0"/>
+          </a:p>
+        </p:txBody>
+      </p:sp>
+      <p:sp>
+        <p:nvSpPr>
+          <p:cNvPr id="38" name="Text 36"/>
+          <p:cNvSpPr/>
+          <p:nvPr/>
+        </p:nvSpPr>
+        <p:spPr>
+          <a:xfrm>
+            <a:off x="6492240" y="2395728"/>
+            <a:ext cx="5129784" cy="237744"/>
+          </a:xfrm>
+          <a:prstGeom prst="rect">
+            <a:avLst/>
+          </a:prstGeom>
+          <a:noFill/>
+          <a:ln/>
+        </p:spPr>
+        <p:txBody>
+          <a:bodyPr wrap="square" lIns="0" tIns="0" rIns="0" bIns="0" rtlCol="0" anchor="ctr"/>
+          <a:lstStyle/>
+          <a:p>
+            <a:pPr indent="0" marL="0">
+              <a:buNone/>
+            </a:pPr>
+            <a:r>
+              <a:rPr lang="en-US" sz="1100" b="1" dirty="0">
+                <a:solidFill>
+                  <a:srgbClr val="FFFFFF"/>
+                </a:solidFill>
+                <a:latin typeface="Pretendard" pitchFamily="34" charset="0"/>
+                <a:ea typeface="Pretendard" pitchFamily="34" charset="-122"/>
+                <a:cs typeface="Pretendard" pitchFamily="34" charset="-120"/>
+              </a:rPr>
+              <a:t>면책 조항</a:t>
+            </a:r>
+            <a:endParaRPr lang="en-US" sz="1100" dirty="0"/>
+          </a:p>
+        </p:txBody>
+      </p:sp>
+      <p:sp>
+        <p:nvSpPr>
+          <p:cNvPr id="39" name="Shape 37"/>
+          <p:cNvSpPr/>
+          <p:nvPr/>
+        </p:nvSpPr>
+        <p:spPr>
+          <a:xfrm>
+            <a:off x="6492240" y="2724912"/>
+            <a:ext cx="5129784" cy="1645920"/>
+          </a:xfrm>
+          <a:prstGeom prst="roundRect">
+            <a:avLst>
+              <a:gd name="adj" fmla="val 2222"/>
+            </a:avLst>
+          </a:prstGeom>
+          <a:solidFill>
+            <a:srgbClr val="1E293B"/>
+          </a:solidFill>
+          <a:ln/>
+        </p:spPr>
+      </p:sp>
+      <p:sp>
+        <p:nvSpPr>
+          <p:cNvPr id="40" name="Text 38"/>
+          <p:cNvSpPr/>
+          <p:nvPr/>
+        </p:nvSpPr>
+        <p:spPr>
+          <a:xfrm>
+            <a:off x="6675120" y="2834640"/>
+            <a:ext cx="4764024" cy="1426464"/>
+          </a:xfrm>
+          <a:prstGeom prst="rect">
+            <a:avLst/>
+          </a:prstGeom>
+          <a:noFill/>
+          <a:ln/>
+        </p:spPr>
+        <p:txBody>
+          <a:bodyPr wrap="square" lIns="0" tIns="0" rIns="0" bIns="0" rtlCol="0" anchor="t"/>
+          <a:lstStyle/>
+          <a:p>
+            <a:pPr indent="0" marL="0">
+              <a:lnSpc>
+                <a:spcPct val="128000"/>
+              </a:lnSpc>
+              <a:buNone/>
+            </a:pPr>
+            <a:r>
+              <a:rPr lang="en-US" sz="850" dirty="0">
+                <a:solidFill>
+                  <a:srgbClr val="94A3B8"/>
+                </a:solidFill>
+                <a:latin typeface="Pretendard" pitchFamily="34" charset="0"/>
+                <a:ea typeface="Pretendard" pitchFamily="34" charset="-122"/>
+                <a:cs typeface="Pretendard" pitchFamily="34" charset="-120"/>
+              </a:rPr>
+              <a:t>본 자료는 투자 권유가 아니며, 기재된 정보의 정확성을 보증하지 않습니다.</a:t>
+            </a:r>
+            <a:endParaRPr lang="en-US" sz="850" dirty="0"/>
+          </a:p>
+        </p:txBody>
+      </p:sp>
+      <p:sp>
+        <p:nvSpPr>
+          <p:cNvPr id="41" name="Shape 39"/>
+          <p:cNvSpPr/>
+          <p:nvPr/>
+        </p:nvSpPr>
+        <p:spPr>
+          <a:xfrm>
+            <a:off x="566928" y="5760720"/>
+            <a:ext cx="11057839" cy="457200"/>
+          </a:xfrm>
+          <a:prstGeom prst="rect">
+            <a:avLst/>
+          </a:prstGeom>
+          <a:solidFill>
+            <a:srgbClr val="4F6A00"/>
+          </a:solidFill>
+          <a:ln/>
+        </p:spPr>
+      </p:sp>
+      <p:sp>
+        <p:nvSpPr>
+          <p:cNvPr id="42" name="Text 40"/>
+          <p:cNvSpPr/>
+          <p:nvPr/>
+        </p:nvSpPr>
+        <p:spPr>
+          <a:xfrm>
+            <a:off x="749808" y="5806440"/>
+            <a:ext cx="10692079" cy="365760"/>
+          </a:xfrm>
+          <a:prstGeom prst="rect">
+            <a:avLst/>
+          </a:prstGeom>
+          <a:noFill/>
+          <a:ln/>
+        </p:spPr>
+        <p:txBody>
+          <a:bodyPr wrap="square" lIns="0" tIns="0" rIns="0" bIns="0" rtlCol="0" anchor="ctr"/>
+          <a:lstStyle/>
+          <a:p>
+            <a:pPr indent="0" marL="0">
+              <a:buNone/>
+            </a:pPr>
+            <a:r>
+              <a:rPr lang="en-US" sz="900" dirty="0">
+                <a:solidFill>
+                  <a:srgbClr val="E8F5CC"/>
+                </a:solidFill>
+                <a:latin typeface="Pretendard" pitchFamily="34" charset="0"/>
+                <a:ea typeface="Pretendard" pitchFamily="34" charset="-122"/>
+                <a:cs typeface="Pretendard" pitchFamily="34" charset="-120"/>
+              </a:rPr>
+              <a:t>리얼티코리아 중개법인 · </a:t>
+            </a:r>
+            <a:endParaRPr lang="en-US" sz="900" dirty="0"/>
+          </a:p>
+        </p:txBody>
+      </p:sp>
+      <p:sp>
+        <p:nvSpPr>
+          <p:cNvPr id="43" name="Text 41"/>
+          <p:cNvSpPr/>
+          <p:nvPr/>
+        </p:nvSpPr>
+        <p:spPr>
+          <a:xfrm>
+            <a:off x="566928" y="6419088"/>
+            <a:ext cx="11057839" cy="201168"/>
+          </a:xfrm>
+          <a:prstGeom prst="rect">
+            <a:avLst/>
+          </a:prstGeom>
+          <a:noFill/>
+          <a:ln/>
+        </p:spPr>
+        <p:txBody>
+          <a:bodyPr wrap="square" lIns="0" tIns="0" rIns="0" bIns="0" rtlCol="0" anchor="ctr"/>
+          <a:lstStyle/>
+          <a:p>
+            <a:pPr algn="ctr" indent="0" marL="0">
+              <a:buNone/>
+            </a:pPr>
+            <a:r>
+              <a:rPr lang="en-US" sz="750" dirty="0">
+                <a:solidFill>
+                  <a:srgbClr val="64748B"/>
+                </a:solidFill>
+                <a:latin typeface="Pretendard" pitchFamily="34" charset="0"/>
+                <a:ea typeface="Pretendard" pitchFamily="34" charset="-122"/>
+                <a:cs typeface="Pretendard" pitchFamily="34" charset="-120"/>
+              </a:rPr>
               <a:t>크리딜  ·    ·  9</a:t>
             </a:r>
             <a:endParaRPr lang="en-US" sz="750" dirty="0"/>
@@ -11765,7 +11662,7 @@
       </p:sp>
       <p:sp>
         <p:nvSpPr>
-          <p:cNvPr id="12" name="Shape 10"/>
+          <p:cNvPr id="44" name="Shape 42"/>
           <p:cNvSpPr/>
           <p:nvPr/>
         </p:nvSpPr>
@@ -11780,7 +11677,7 @@
           <a:noFill/>
           <a:ln w="6350">
             <a:solidFill>
-              <a:srgbClr val="C8FF00"/>
+              <a:srgbClr val="6B8E00"/>
             </a:solidFill>
             <a:prstDash val="solid"/>
           </a:ln>

</xml_diff>